<commit_message>
Put the real per-class test counts on the split slide
The slide carried "approximately 5" for most classes. It now lists all
fourteen with the counts from both splits, and the seven classes that
carry five test videos or fewer are marked.

Three independent checks reconcile against REVIEW_14CLASS.md: the
standard column sums to 290, the first-path column to 296, and exactly
seven classes sit at five or fewer, which is what the noise discussion
in that file states.

Co-Authored-By: Claude Opus 5 <noreply@anthropic.com>
Claude-Session: https://claude.ai/code/session_01LTN1ToAz7S67GVeppJLK8m
</commit_message>
<xml_diff>
--- a/thesis/Defense_Slides.pptx
+++ b/thesis/Defense_Slides.pptx
@@ -35687,7 +35687,7 @@
           </p:nvPr>
         </p:nvGraphicFramePr>
         <p:xfrm>
-          <a:off x="548640" y="1600200"/>
+          <a:off x="548640" y="1572768"/>
           <a:ext cx="6766560" cy="914400"/>
         </p:xfrm>
         <a:graphic>
@@ -35699,7 +35699,7 @@
                 <a:gridCol w="1737360"/>
                 <a:gridCol w="1737360"/>
               </a:tblGrid>
-              <a:tr h="283464">
+              <a:tr h="246888">
                 <a:tc>
                   <a:txBody>
                     <a:bodyPr/>
@@ -35709,7 +35709,7 @@
                         <a:buNone/>
                       </a:pPr>
                       <a:r>
-                        <a:rPr lang="en-US" sz="1200" b="1" dirty="0">
+                        <a:rPr lang="en-US" sz="1150" b="1" dirty="0">
                           <a:solidFill>
                             <a:srgbClr val="FFFFFF"/>
                           </a:solidFill>
@@ -35719,7 +35719,7 @@
                         </a:rPr>
                         <a:t>کلاس</a:t>
                       </a:r>
-                      <a:endParaRPr lang="en-US" sz="1200" dirty="0">
+                      <a:endParaRPr lang="en-US" sz="1150" dirty="0">
                         <a:latin typeface="Arial" charset="0"/>
                         <a:ea typeface="Arial" charset="0"/>
                         <a:cs typeface="Arial" charset="0"/>
@@ -35777,7 +35777,7 @@
                         <a:buNone/>
                       </a:pPr>
                       <a:r>
-                        <a:rPr lang="en-US" sz="1200" b="1" dirty="0">
+                        <a:rPr lang="en-US" sz="1150" b="1" dirty="0">
                           <a:solidFill>
                             <a:srgbClr val="FFFFFF"/>
                           </a:solidFill>
@@ -35785,9 +35785,9 @@
                           <a:ea typeface="Arial" pitchFamily="34" charset="-122"/>
                           <a:cs typeface="Arial" pitchFamily="34" charset="-120"/>
                         </a:rPr>
-                        <a:t>تقسیم مسیر اول</a:t>
+                        <a:t>تقسیم استاندارد</a:t>
                       </a:r>
-                      <a:endParaRPr lang="en-US" sz="1200" dirty="0">
+                      <a:endParaRPr lang="en-US" sz="1150" dirty="0">
                         <a:latin typeface="Arial" charset="0"/>
                         <a:ea typeface="Arial" charset="0"/>
                         <a:cs typeface="Arial" charset="0"/>
@@ -35845,7 +35845,7 @@
                         <a:buNone/>
                       </a:pPr>
                       <a:r>
-                        <a:rPr lang="en-US" sz="1200" b="1" dirty="0">
+                        <a:rPr lang="en-US" sz="1150" b="1" dirty="0">
                           <a:solidFill>
                             <a:srgbClr val="FFFFFF"/>
                           </a:solidFill>
@@ -35853,9 +35853,9 @@
                           <a:ea typeface="Arial" pitchFamily="34" charset="-122"/>
                           <a:cs typeface="Arial" pitchFamily="34" charset="-120"/>
                         </a:rPr>
-                        <a:t>تقسیم استاندارد</a:t>
+                        <a:t>تقسیم مسیر اول</a:t>
                       </a:r>
-                      <a:endParaRPr lang="en-US" sz="1200" dirty="0">
+                      <a:endParaRPr lang="en-US" sz="1150" dirty="0">
                         <a:latin typeface="Arial" charset="0"/>
                         <a:ea typeface="Arial" charset="0"/>
                         <a:cs typeface="Arial" charset="0"/>
@@ -35905,7 +35905,7 @@
                   </a:tcPr>
                 </a:tc>
               </a:tr>
-              <a:tr h="283464">
+              <a:tr h="246888">
                 <a:tc>
                   <a:txBody>
                     <a:bodyPr/>
@@ -35915,7 +35915,7 @@
                         <a:buNone/>
                       </a:pPr>
                       <a:r>
-                        <a:rPr lang="en-US" sz="1150" dirty="0">
+                        <a:rPr lang="en-US" sz="1100" dirty="0">
                           <a:solidFill>
                             <a:srgbClr val="1B2236"/>
                           </a:solidFill>
@@ -35925,7 +35925,7 @@
                         </a:rPr>
                         <a:t>Normal — عادی</a:t>
                       </a:r>
-                      <a:endParaRPr lang="en-US" sz="1150" dirty="0">
+                      <a:endParaRPr lang="en-US" sz="1100" dirty="0">
                         <a:latin typeface="Arial" charset="0"/>
                         <a:ea typeface="Arial" charset="0"/>
                         <a:cs typeface="Arial" charset="0"/>
@@ -35983,7 +35983,7 @@
                         <a:buNone/>
                       </a:pPr>
                       <a:r>
-                        <a:rPr lang="en-US" sz="1150" dirty="0">
+                        <a:rPr lang="en-US" sz="1100" dirty="0">
                           <a:solidFill>
                             <a:srgbClr val="1B2236"/>
                           </a:solidFill>
@@ -35991,9 +35991,9 @@
                           <a:ea typeface="Arial" pitchFamily="34" charset="-122"/>
                           <a:cs typeface="Arial" pitchFamily="34" charset="-120"/>
                         </a:rPr>
-                        <a:t>148</a:t>
+                        <a:t>150</a:t>
                       </a:r>
-                      <a:endParaRPr lang="en-US" sz="1150" dirty="0">
+                      <a:endParaRPr lang="en-US" sz="1100" dirty="0">
                         <a:latin typeface="Arial" charset="0"/>
                         <a:ea typeface="Arial" charset="0"/>
                         <a:cs typeface="Arial" charset="0"/>
@@ -36051,7 +36051,7 @@
                         <a:buNone/>
                       </a:pPr>
                       <a:r>
-                        <a:rPr lang="en-US" sz="1150" dirty="0">
+                        <a:rPr lang="en-US" sz="1100" dirty="0">
                           <a:solidFill>
                             <a:srgbClr val="1B2236"/>
                           </a:solidFill>
@@ -36059,9 +36059,9 @@
                           <a:ea typeface="Arial" pitchFamily="34" charset="-122"/>
                           <a:cs typeface="Arial" pitchFamily="34" charset="-120"/>
                         </a:rPr>
-                        <a:t>150</a:t>
+                        <a:t>148</a:t>
                       </a:r>
-                      <a:endParaRPr lang="en-US" sz="1150" dirty="0">
+                      <a:endParaRPr lang="en-US" sz="1100" dirty="0">
                         <a:latin typeface="Arial" charset="0"/>
                         <a:ea typeface="Arial" charset="0"/>
                         <a:cs typeface="Arial" charset="0"/>
@@ -36111,7 +36111,7 @@
                   </a:tcPr>
                 </a:tc>
               </a:tr>
-              <a:tr h="283464">
+              <a:tr h="246888">
                 <a:tc>
                   <a:txBody>
                     <a:bodyPr/>
@@ -36121,7 +36121,7 @@
                         <a:buNone/>
                       </a:pPr>
                       <a:r>
-                        <a:rPr lang="en-US" sz="1150" dirty="0">
+                        <a:rPr lang="en-US" sz="1100" dirty="0">
                           <a:solidFill>
                             <a:srgbClr val="1B2236"/>
                           </a:solidFill>
@@ -36129,9 +36129,9 @@
                           <a:ea typeface="Arial" pitchFamily="34" charset="-122"/>
                           <a:cs typeface="Arial" pitchFamily="34" charset="-120"/>
                         </a:rPr>
-                        <a:t>Robbery — سرقت</a:t>
+                        <a:t>RoadAccidents — تصادف رانندگی</a:t>
                       </a:r>
-                      <a:endParaRPr lang="en-US" sz="1150" dirty="0">
+                      <a:endParaRPr lang="en-US" sz="1100" dirty="0">
                         <a:latin typeface="Arial" charset="0"/>
                         <a:ea typeface="Arial" charset="0"/>
                         <a:cs typeface="Arial" charset="0"/>
@@ -36189,7 +36189,7 @@
                         <a:buNone/>
                       </a:pPr>
                       <a:r>
-                        <a:rPr lang="en-US" sz="1150" dirty="0">
+                        <a:rPr lang="en-US" sz="1100" dirty="0">
                           <a:solidFill>
                             <a:srgbClr val="1B2236"/>
                           </a:solidFill>
@@ -36199,7 +36199,7 @@
                         </a:rPr>
                         <a:t>23</a:t>
                       </a:r>
-                      <a:endParaRPr lang="en-US" sz="1150" dirty="0">
+                      <a:endParaRPr lang="en-US" sz="1100" dirty="0">
                         <a:latin typeface="Arial" charset="0"/>
                         <a:ea typeface="Arial" charset="0"/>
                         <a:cs typeface="Arial" charset="0"/>
@@ -36257,7 +36257,7 @@
                         <a:buNone/>
                       </a:pPr>
                       <a:r>
-                        <a:rPr lang="en-US" sz="1150" dirty="0">
+                        <a:rPr lang="en-US" sz="1100" dirty="0">
                           <a:solidFill>
                             <a:srgbClr val="1B2236"/>
                           </a:solidFill>
@@ -36265,9 +36265,9 @@
                           <a:ea typeface="Arial" pitchFamily="34" charset="-122"/>
                           <a:cs typeface="Arial" pitchFamily="34" charset="-120"/>
                         </a:rPr>
-                        <a:t>≈ 5</a:t>
+                        <a:t>23</a:t>
                       </a:r>
-                      <a:endParaRPr lang="en-US" sz="1150" dirty="0">
+                      <a:endParaRPr lang="en-US" sz="1100" dirty="0">
                         <a:latin typeface="Arial" charset="0"/>
                         <a:ea typeface="Arial" charset="0"/>
                         <a:cs typeface="Arial" charset="0"/>
@@ -36317,7 +36317,7 @@
                   </a:tcPr>
                 </a:tc>
               </a:tr>
-              <a:tr h="283464">
+              <a:tr h="246888">
                 <a:tc>
                   <a:txBody>
                     <a:bodyPr/>
@@ -36327,7 +36327,7 @@
                         <a:buNone/>
                       </a:pPr>
                       <a:r>
-                        <a:rPr lang="en-US" sz="1150" dirty="0">
+                        <a:rPr lang="en-US" sz="1100" dirty="0">
                           <a:solidFill>
                             <a:srgbClr val="1B2236"/>
                           </a:solidFill>
@@ -36335,9 +36335,9 @@
                           <a:ea typeface="Arial" pitchFamily="34" charset="-122"/>
                           <a:cs typeface="Arial" pitchFamily="34" charset="-120"/>
                         </a:rPr>
-                        <a:t>RoadAccidents — تصادف</a:t>
+                        <a:t>Shooting — تیراندازی</a:t>
                       </a:r>
-                      <a:endParaRPr lang="en-US" sz="1150" dirty="0">
+                      <a:endParaRPr lang="en-US" sz="1100" dirty="0">
                         <a:latin typeface="Arial" charset="0"/>
                         <a:ea typeface="Arial" charset="0"/>
                         <a:cs typeface="Arial" charset="0"/>
@@ -36395,7 +36395,7 @@
                         <a:buNone/>
                       </a:pPr>
                       <a:r>
-                        <a:rPr lang="en-US" sz="1150" dirty="0">
+                        <a:rPr lang="en-US" sz="1100" dirty="0">
                           <a:solidFill>
                             <a:srgbClr val="1B2236"/>
                           </a:solidFill>
@@ -36405,7 +36405,7 @@
                         </a:rPr>
                         <a:t>23</a:t>
                       </a:r>
-                      <a:endParaRPr lang="en-US" sz="1150" dirty="0">
+                      <a:endParaRPr lang="en-US" sz="1100" dirty="0">
                         <a:latin typeface="Arial" charset="0"/>
                         <a:ea typeface="Arial" charset="0"/>
                         <a:cs typeface="Arial" charset="0"/>
@@ -36463,7 +36463,7 @@
                         <a:buNone/>
                       </a:pPr>
                       <a:r>
-                        <a:rPr lang="en-US" sz="1150" dirty="0">
+                        <a:rPr lang="en-US" sz="1100" dirty="0">
                           <a:solidFill>
                             <a:srgbClr val="1B2236"/>
                           </a:solidFill>
@@ -36471,9 +36471,9 @@
                           <a:ea typeface="Arial" pitchFamily="34" charset="-122"/>
                           <a:cs typeface="Arial" pitchFamily="34" charset="-120"/>
                         </a:rPr>
-                        <a:t>≈ 23</a:t>
+                        <a:t>8</a:t>
                       </a:r>
-                      <a:endParaRPr lang="en-US" sz="1150" dirty="0">
+                      <a:endParaRPr lang="en-US" sz="1100" dirty="0">
                         <a:latin typeface="Arial" charset="0"/>
                         <a:ea typeface="Arial" charset="0"/>
                         <a:cs typeface="Arial" charset="0"/>
@@ -36523,7 +36523,7 @@
                   </a:tcPr>
                 </a:tc>
               </a:tr>
-              <a:tr h="283464">
+              <a:tr h="246888">
                 <a:tc>
                   <a:txBody>
                     <a:bodyPr/>
@@ -36533,7 +36533,7 @@
                         <a:buNone/>
                       </a:pPr>
                       <a:r>
-                        <a:rPr lang="en-US" sz="1150" dirty="0">
+                        <a:rPr lang="en-US" sz="1100" dirty="0">
                           <a:solidFill>
                             <a:srgbClr val="1B2236"/>
                           </a:solidFill>
@@ -36541,9 +36541,9 @@
                           <a:ea typeface="Arial" pitchFamily="34" charset="-122"/>
                           <a:cs typeface="Arial" pitchFamily="34" charset="-120"/>
                         </a:rPr>
-                        <a:t>Stealing — دزدی</a:t>
+                        <a:t>Explosion — انفجار</a:t>
                       </a:r>
-                      <a:endParaRPr lang="en-US" sz="1150" dirty="0">
+                      <a:endParaRPr lang="en-US" sz="1100" dirty="0">
                         <a:latin typeface="Arial" charset="0"/>
                         <a:ea typeface="Arial" charset="0"/>
                         <a:cs typeface="Arial" charset="0"/>
@@ -36601,7 +36601,7 @@
                         <a:buNone/>
                       </a:pPr>
                       <a:r>
-                        <a:rPr lang="en-US" sz="1150" dirty="0">
+                        <a:rPr lang="en-US" sz="1100" dirty="0">
                           <a:solidFill>
                             <a:srgbClr val="1B2236"/>
                           </a:solidFill>
@@ -36609,9 +36609,9 @@
                           <a:ea typeface="Arial" pitchFamily="34" charset="-122"/>
                           <a:cs typeface="Arial" pitchFamily="34" charset="-120"/>
                         </a:rPr>
-                        <a:t>15</a:t>
+                        <a:t>21</a:t>
                       </a:r>
-                      <a:endParaRPr lang="en-US" sz="1150" dirty="0">
+                      <a:endParaRPr lang="en-US" sz="1100" dirty="0">
                         <a:latin typeface="Arial" charset="0"/>
                         <a:ea typeface="Arial" charset="0"/>
                         <a:cs typeface="Arial" charset="0"/>
@@ -36669,7 +36669,7 @@
                         <a:buNone/>
                       </a:pPr>
                       <a:r>
-                        <a:rPr lang="en-US" sz="1150" dirty="0">
+                        <a:rPr lang="en-US" sz="1100" dirty="0">
                           <a:solidFill>
                             <a:srgbClr val="1B2236"/>
                           </a:solidFill>
@@ -36677,9 +36677,9 @@
                           <a:ea typeface="Arial" pitchFamily="34" charset="-122"/>
                           <a:cs typeface="Arial" pitchFamily="34" charset="-120"/>
                         </a:rPr>
-                        <a:t>≈ 5</a:t>
+                        <a:t>8</a:t>
                       </a:r>
-                      <a:endParaRPr lang="en-US" sz="1150" dirty="0">
+                      <a:endParaRPr lang="en-US" sz="1100" dirty="0">
                         <a:latin typeface="Arial" charset="0"/>
                         <a:ea typeface="Arial" charset="0"/>
                         <a:cs typeface="Arial" charset="0"/>
@@ -36729,7 +36729,7 @@
                   </a:tcPr>
                 </a:tc>
               </a:tr>
-              <a:tr h="283464">
+              <a:tr h="246888">
                 <a:tc>
                   <a:txBody>
                     <a:bodyPr/>
@@ -36739,7 +36739,7 @@
                         <a:buNone/>
                       </a:pPr>
                       <a:r>
-                        <a:rPr lang="en-US" sz="1150" dirty="0">
+                        <a:rPr lang="en-US" sz="1100" dirty="0">
                           <a:solidFill>
                             <a:srgbClr val="1B2236"/>
                           </a:solidFill>
@@ -36747,9 +36747,9 @@
                           <a:ea typeface="Arial" pitchFamily="34" charset="-122"/>
                           <a:cs typeface="Arial" pitchFamily="34" charset="-120"/>
                         </a:rPr>
-                        <a:t>Burglary — سرقت از منزل</a:t>
+                        <a:t>Shoplifting — دزدی از مغازه</a:t>
                       </a:r>
-                      <a:endParaRPr lang="en-US" sz="1150" dirty="0">
+                      <a:endParaRPr lang="en-US" sz="1100" dirty="0">
                         <a:latin typeface="Arial" charset="0"/>
                         <a:ea typeface="Arial" charset="0"/>
                         <a:cs typeface="Arial" charset="0"/>
@@ -36807,7 +36807,7 @@
                         <a:buNone/>
                       </a:pPr>
                       <a:r>
-                        <a:rPr lang="en-US" sz="1150" dirty="0">
+                        <a:rPr lang="en-US" sz="1100" dirty="0">
                           <a:solidFill>
                             <a:srgbClr val="1B2236"/>
                           </a:solidFill>
@@ -36815,9 +36815,9 @@
                           <a:ea typeface="Arial" pitchFamily="34" charset="-122"/>
                           <a:cs typeface="Arial" pitchFamily="34" charset="-120"/>
                         </a:rPr>
-                        <a:t>15</a:t>
+                        <a:t>21</a:t>
                       </a:r>
-                      <a:endParaRPr lang="en-US" sz="1150" dirty="0">
+                      <a:endParaRPr lang="en-US" sz="1100" dirty="0">
                         <a:latin typeface="Arial" charset="0"/>
                         <a:ea typeface="Arial" charset="0"/>
                         <a:cs typeface="Arial" charset="0"/>
@@ -36875,7 +36875,7 @@
                         <a:buNone/>
                       </a:pPr>
                       <a:r>
-                        <a:rPr lang="en-US" sz="1150" dirty="0">
+                        <a:rPr lang="en-US" sz="1100" dirty="0">
                           <a:solidFill>
                             <a:srgbClr val="1B2236"/>
                           </a:solidFill>
@@ -36883,9 +36883,9 @@
                           <a:ea typeface="Arial" pitchFamily="34" charset="-122"/>
                           <a:cs typeface="Arial" pitchFamily="34" charset="-120"/>
                         </a:rPr>
-                        <a:t>≈ 5</a:t>
+                        <a:t>8</a:t>
                       </a:r>
-                      <a:endParaRPr lang="en-US" sz="1150" dirty="0">
+                      <a:endParaRPr lang="en-US" sz="1100" dirty="0">
                         <a:latin typeface="Arial" charset="0"/>
                         <a:ea typeface="Arial" charset="0"/>
                         <a:cs typeface="Arial" charset="0"/>
@@ -36935,7 +36935,7 @@
                   </a:tcPr>
                 </a:tc>
               </a:tr>
-              <a:tr h="283464">
+              <a:tr h="246888">
                 <a:tc>
                   <a:txBody>
                     <a:bodyPr/>
@@ -36945,7 +36945,7 @@
                         <a:buNone/>
                       </a:pPr>
                       <a:r>
-                        <a:rPr lang="en-US" sz="1150" dirty="0">
+                        <a:rPr lang="en-US" sz="1100" dirty="0">
                           <a:solidFill>
                             <a:srgbClr val="1B2236"/>
                           </a:solidFill>
@@ -36953,9 +36953,9 @@
                           <a:ea typeface="Arial" pitchFamily="34" charset="-122"/>
                           <a:cs typeface="Arial" pitchFamily="34" charset="-120"/>
                         </a:rPr>
-                        <a:t>Shoplifting — دزدی از مغازه</a:t>
+                        <a:t>Burglary — سرقت از منزل</a:t>
                       </a:r>
-                      <a:endParaRPr lang="en-US" sz="1150" dirty="0">
+                      <a:endParaRPr lang="en-US" sz="1100" dirty="0">
                         <a:latin typeface="Arial" charset="0"/>
                         <a:ea typeface="Arial" charset="0"/>
                         <a:cs typeface="Arial" charset="0"/>
@@ -37013,7 +37013,7 @@
                         <a:buNone/>
                       </a:pPr>
                       <a:r>
-                        <a:rPr lang="en-US" sz="1150" dirty="0">
+                        <a:rPr lang="en-US" sz="1100" dirty="0">
                           <a:solidFill>
                             <a:srgbClr val="1B2236"/>
                           </a:solidFill>
@@ -37021,9 +37021,9 @@
                           <a:ea typeface="Arial" pitchFamily="34" charset="-122"/>
                           <a:cs typeface="Arial" pitchFamily="34" charset="-120"/>
                         </a:rPr>
-                        <a:t>8</a:t>
+                        <a:t>13</a:t>
                       </a:r>
-                      <a:endParaRPr lang="en-US" sz="1150" dirty="0">
+                      <a:endParaRPr lang="en-US" sz="1100" dirty="0">
                         <a:latin typeface="Arial" charset="0"/>
                         <a:ea typeface="Arial" charset="0"/>
                         <a:cs typeface="Arial" charset="0"/>
@@ -37081,7 +37081,7 @@
                         <a:buNone/>
                       </a:pPr>
                       <a:r>
-                        <a:rPr lang="en-US" sz="1150" dirty="0">
+                        <a:rPr lang="en-US" sz="1100" dirty="0">
                           <a:solidFill>
                             <a:srgbClr val="1B2236"/>
                           </a:solidFill>
@@ -37089,9 +37089,9 @@
                           <a:ea typeface="Arial" pitchFamily="34" charset="-122"/>
                           <a:cs typeface="Arial" pitchFamily="34" charset="-120"/>
                         </a:rPr>
-                        <a:t>≈ 5</a:t>
+                        <a:t>15</a:t>
                       </a:r>
-                      <a:endParaRPr lang="en-US" sz="1150" dirty="0">
+                      <a:endParaRPr lang="en-US" sz="1100" dirty="0">
                         <a:latin typeface="Arial" charset="0"/>
                         <a:ea typeface="Arial" charset="0"/>
                         <a:cs typeface="Arial" charset="0"/>
@@ -37141,7 +37141,7 @@
                   </a:tcPr>
                 </a:tc>
               </a:tr>
-              <a:tr h="283464">
+              <a:tr h="246888">
                 <a:tc>
                   <a:txBody>
                     <a:bodyPr/>
@@ -37151,7 +37151,7 @@
                         <a:buNone/>
                       </a:pPr>
                       <a:r>
-                        <a:rPr lang="en-US" sz="1150" dirty="0">
+                        <a:rPr lang="en-US" sz="1100" dirty="0">
                           <a:solidFill>
                             <a:srgbClr val="1B2236"/>
                           </a:solidFill>
@@ -37159,9 +37159,9 @@
                           <a:ea typeface="Arial" pitchFamily="34" charset="-122"/>
                           <a:cs typeface="Arial" pitchFamily="34" charset="-120"/>
                         </a:rPr>
-                        <a:t>Fighting — درگیری</a:t>
+                        <a:t>Arson — آتش‌افروزی</a:t>
                       </a:r>
-                      <a:endParaRPr lang="en-US" sz="1150" dirty="0">
+                      <a:endParaRPr lang="en-US" sz="1100" dirty="0">
                         <a:latin typeface="Arial" charset="0"/>
                         <a:ea typeface="Arial" charset="0"/>
                         <a:cs typeface="Arial" charset="0"/>
@@ -37219,7 +37219,7 @@
                         <a:buNone/>
                       </a:pPr>
                       <a:r>
-                        <a:rPr lang="en-US" sz="1150" dirty="0">
+                        <a:rPr lang="en-US" sz="1100" dirty="0">
                           <a:solidFill>
                             <a:srgbClr val="1B2236"/>
                           </a:solidFill>
@@ -37227,9 +37227,9 @@
                           <a:ea typeface="Arial" pitchFamily="34" charset="-122"/>
                           <a:cs typeface="Arial" pitchFamily="34" charset="-120"/>
                         </a:rPr>
-                        <a:t>8</a:t>
+                        <a:t>9</a:t>
                       </a:r>
-                      <a:endParaRPr lang="en-US" sz="1150" dirty="0">
+                      <a:endParaRPr lang="en-US" sz="1100" dirty="0">
                         <a:latin typeface="Arial" charset="0"/>
                         <a:ea typeface="Arial" charset="0"/>
                         <a:cs typeface="Arial" charset="0"/>
@@ -37287,7 +37287,7 @@
                         <a:buNone/>
                       </a:pPr>
                       <a:r>
-                        <a:rPr lang="en-US" sz="1150" dirty="0">
+                        <a:rPr lang="en-US" sz="1100" dirty="0">
                           <a:solidFill>
                             <a:srgbClr val="1B2236"/>
                           </a:solidFill>
@@ -37295,9 +37295,9 @@
                           <a:ea typeface="Arial" pitchFamily="34" charset="-122"/>
                           <a:cs typeface="Arial" pitchFamily="34" charset="-120"/>
                         </a:rPr>
-                        <a:t>≈ 5</a:t>
+                        <a:t>8</a:t>
                       </a:r>
-                      <a:endParaRPr lang="en-US" sz="1150" dirty="0">
+                      <a:endParaRPr lang="en-US" sz="1100" dirty="0">
                         <a:latin typeface="Arial" charset="0"/>
                         <a:ea typeface="Arial" charset="0"/>
                         <a:cs typeface="Arial" charset="0"/>
@@ -37347,7 +37347,7 @@
                   </a:tcPr>
                 </a:tc>
               </a:tr>
-              <a:tr h="283464">
+              <a:tr h="246888">
                 <a:tc>
                   <a:txBody>
                     <a:bodyPr/>
@@ -37357,17 +37357,17 @@
                         <a:buNone/>
                       </a:pPr>
                       <a:r>
-                        <a:rPr lang="en-US" sz="1150" dirty="0">
+                        <a:rPr lang="en-US" sz="1100" b="1" dirty="0">
                           <a:solidFill>
-                            <a:srgbClr val="1B2236"/>
+                            <a:srgbClr val="16264F"/>
                           </a:solidFill>
                           <a:latin typeface="Arial" pitchFamily="34" charset="0"/>
                           <a:ea typeface="Arial" pitchFamily="34" charset="-122"/>
                           <a:cs typeface="Arial" pitchFamily="34" charset="-120"/>
                         </a:rPr>
-                        <a:t>Assault — تعرض</a:t>
+                        <a:t>Arrest — بازداشت</a:t>
                       </a:r>
-                      <a:endParaRPr lang="en-US" sz="1150" dirty="0">
+                      <a:endParaRPr lang="en-US" sz="1100" dirty="0">
                         <a:latin typeface="Arial" charset="0"/>
                         <a:ea typeface="Arial" charset="0"/>
                         <a:cs typeface="Arial" charset="0"/>
@@ -37412,7 +37412,7 @@
                       <a:tailEnd type="none" w="med" len="med"/>
                     </a:lnB>
                     <a:solidFill>
-                      <a:srgbClr val="FFFFFF"/>
+                      <a:srgbClr val="FFF2DC"/>
                     </a:solidFill>
                   </a:tcPr>
                 </a:tc>
@@ -37425,17 +37425,17 @@
                         <a:buNone/>
                       </a:pPr>
                       <a:r>
-                        <a:rPr lang="en-US" sz="1150" dirty="0">
+                        <a:rPr lang="en-US" sz="1100" b="1" dirty="0">
                           <a:solidFill>
-                            <a:srgbClr val="1B2236"/>
+                            <a:srgbClr val="16264F"/>
                           </a:solidFill>
                           <a:latin typeface="Arial" pitchFamily="34" charset="0"/>
                           <a:ea typeface="Arial" pitchFamily="34" charset="-122"/>
                           <a:cs typeface="Arial" pitchFamily="34" charset="-120"/>
                         </a:rPr>
-                        <a:t>8</a:t>
+                        <a:t>5</a:t>
                       </a:r>
-                      <a:endParaRPr lang="en-US" sz="1150" dirty="0">
+                      <a:endParaRPr lang="en-US" sz="1100" dirty="0">
                         <a:latin typeface="Arial" charset="0"/>
                         <a:ea typeface="Arial" charset="0"/>
                         <a:cs typeface="Arial" charset="0"/>
@@ -37480,7 +37480,7 @@
                       <a:tailEnd type="none" w="med" len="med"/>
                     </a:lnB>
                     <a:solidFill>
-                      <a:srgbClr val="FFFFFF"/>
+                      <a:srgbClr val="FFF2DC"/>
                     </a:solidFill>
                   </a:tcPr>
                 </a:tc>
@@ -37493,17 +37493,17 @@
                         <a:buNone/>
                       </a:pPr>
                       <a:r>
-                        <a:rPr lang="en-US" sz="1150" dirty="0">
+                        <a:rPr lang="en-US" sz="1100" b="1" dirty="0">
                           <a:solidFill>
-                            <a:srgbClr val="1B2236"/>
+                            <a:srgbClr val="16264F"/>
                           </a:solidFill>
                           <a:latin typeface="Arial" pitchFamily="34" charset="0"/>
                           <a:ea typeface="Arial" pitchFamily="34" charset="-122"/>
                           <a:cs typeface="Arial" pitchFamily="34" charset="-120"/>
                         </a:rPr>
-                        <a:t>≈ 5</a:t>
+                        <a:t>8</a:t>
                       </a:r>
-                      <a:endParaRPr lang="en-US" sz="1150" dirty="0">
+                      <a:endParaRPr lang="en-US" sz="1100" dirty="0">
                         <a:latin typeface="Arial" charset="0"/>
                         <a:ea typeface="Arial" charset="0"/>
                         <a:cs typeface="Arial" charset="0"/>
@@ -37548,12 +37548,12 @@
                       <a:tailEnd type="none" w="med" len="med"/>
                     </a:lnB>
                     <a:solidFill>
-                      <a:srgbClr val="FFFFFF"/>
+                      <a:srgbClr val="FFF2DC"/>
                     </a:solidFill>
                   </a:tcPr>
                 </a:tc>
               </a:tr>
-              <a:tr h="283464">
+              <a:tr h="246888">
                 <a:tc>
                   <a:txBody>
                     <a:bodyPr/>
@@ -37563,17 +37563,17 @@
                         <a:buNone/>
                       </a:pPr>
                       <a:r>
-                        <a:rPr lang="en-US" sz="1150" dirty="0">
+                        <a:rPr lang="en-US" sz="1100" b="1" dirty="0">
                           <a:solidFill>
-                            <a:srgbClr val="1B2236"/>
+                            <a:srgbClr val="16264F"/>
                           </a:solidFill>
                           <a:latin typeface="Arial" pitchFamily="34" charset="0"/>
                           <a:ea typeface="Arial" pitchFamily="34" charset="-122"/>
                           <a:cs typeface="Arial" pitchFamily="34" charset="-120"/>
                         </a:rPr>
-                        <a:t>Vandalism — تخریب</a:t>
+                        <a:t>Fighting — درگیری</a:t>
                       </a:r>
-                      <a:endParaRPr lang="en-US" sz="1150" dirty="0">
+                      <a:endParaRPr lang="en-US" sz="1100" dirty="0">
                         <a:latin typeface="Arial" charset="0"/>
                         <a:ea typeface="Arial" charset="0"/>
                         <a:cs typeface="Arial" charset="0"/>
@@ -37618,7 +37618,7 @@
                       <a:tailEnd type="none" w="med" len="med"/>
                     </a:lnB>
                     <a:solidFill>
-                      <a:srgbClr val="EDF1F8"/>
+                      <a:srgbClr val="FFF2DC"/>
                     </a:solidFill>
                   </a:tcPr>
                 </a:tc>
@@ -37631,17 +37631,17 @@
                         <a:buNone/>
                       </a:pPr>
                       <a:r>
-                        <a:rPr lang="en-US" sz="1150" dirty="0">
+                        <a:rPr lang="en-US" sz="1100" b="1" dirty="0">
                           <a:solidFill>
-                            <a:srgbClr val="1B2236"/>
+                            <a:srgbClr val="16264F"/>
                           </a:solidFill>
                           <a:latin typeface="Arial" pitchFamily="34" charset="0"/>
                           <a:ea typeface="Arial" pitchFamily="34" charset="-122"/>
                           <a:cs typeface="Arial" pitchFamily="34" charset="-120"/>
                         </a:rPr>
-                        <a:t>8</a:t>
+                        <a:t>5</a:t>
                       </a:r>
-                      <a:endParaRPr lang="en-US" sz="1150" dirty="0">
+                      <a:endParaRPr lang="en-US" sz="1100" dirty="0">
                         <a:latin typeface="Arial" charset="0"/>
                         <a:ea typeface="Arial" charset="0"/>
                         <a:cs typeface="Arial" charset="0"/>
@@ -37686,7 +37686,7 @@
                       <a:tailEnd type="none" w="med" len="med"/>
                     </a:lnB>
                     <a:solidFill>
-                      <a:srgbClr val="EDF1F8"/>
+                      <a:srgbClr val="FFF2DC"/>
                     </a:solidFill>
                   </a:tcPr>
                 </a:tc>
@@ -37699,17 +37699,17 @@
                         <a:buNone/>
                       </a:pPr>
                       <a:r>
-                        <a:rPr lang="en-US" sz="1150" dirty="0">
+                        <a:rPr lang="en-US" sz="1100" b="1" dirty="0">
                           <a:solidFill>
-                            <a:srgbClr val="1B2236"/>
+                            <a:srgbClr val="16264F"/>
                           </a:solidFill>
                           <a:latin typeface="Arial" pitchFamily="34" charset="0"/>
                           <a:ea typeface="Arial" pitchFamily="34" charset="-122"/>
                           <a:cs typeface="Arial" pitchFamily="34" charset="-120"/>
                         </a:rPr>
-                        <a:t>≈ 5</a:t>
+                        <a:t>8</a:t>
                       </a:r>
-                      <a:endParaRPr lang="en-US" sz="1150" dirty="0">
+                      <a:endParaRPr lang="en-US" sz="1100" dirty="0">
                         <a:latin typeface="Arial" charset="0"/>
                         <a:ea typeface="Arial" charset="0"/>
                         <a:cs typeface="Arial" charset="0"/>
@@ -37754,12 +37754,12 @@
                       <a:tailEnd type="none" w="med" len="med"/>
                     </a:lnB>
                     <a:solidFill>
-                      <a:srgbClr val="EDF1F8"/>
+                      <a:srgbClr val="FFF2DC"/>
                     </a:solidFill>
                   </a:tcPr>
                 </a:tc>
               </a:tr>
-              <a:tr h="283464">
+              <a:tr h="246888">
                 <a:tc>
                   <a:txBody>
                     <a:bodyPr/>
@@ -37769,17 +37769,17 @@
                         <a:buNone/>
                       </a:pPr>
                       <a:r>
-                        <a:rPr lang="en-US" sz="1150" dirty="0">
+                        <a:rPr lang="en-US" sz="1100" b="1" dirty="0">
                           <a:solidFill>
-                            <a:srgbClr val="1B2236"/>
+                            <a:srgbClr val="16264F"/>
                           </a:solidFill>
                           <a:latin typeface="Arial" pitchFamily="34" charset="0"/>
                           <a:ea typeface="Arial" pitchFamily="34" charset="-122"/>
                           <a:cs typeface="Arial" pitchFamily="34" charset="-120"/>
                         </a:rPr>
-                        <a:t>Abuse — سوءاستفاده</a:t>
+                        <a:t>Robbery — سرقت</a:t>
                       </a:r>
-                      <a:endParaRPr lang="en-US" sz="1150" dirty="0">
+                      <a:endParaRPr lang="en-US" sz="1100" dirty="0">
                         <a:latin typeface="Arial" charset="0"/>
                         <a:ea typeface="Arial" charset="0"/>
                         <a:cs typeface="Arial" charset="0"/>
@@ -37824,7 +37824,7 @@
                       <a:tailEnd type="none" w="med" len="med"/>
                     </a:lnB>
                     <a:solidFill>
-                      <a:srgbClr val="FFFFFF"/>
+                      <a:srgbClr val="FFF2DC"/>
                     </a:solidFill>
                   </a:tcPr>
                 </a:tc>
@@ -37837,17 +37837,17 @@
                         <a:buNone/>
                       </a:pPr>
                       <a:r>
-                        <a:rPr lang="en-US" sz="1150" dirty="0">
+                        <a:rPr lang="en-US" sz="1100" b="1" dirty="0">
                           <a:solidFill>
-                            <a:srgbClr val="1B2236"/>
+                            <a:srgbClr val="16264F"/>
                           </a:solidFill>
                           <a:latin typeface="Arial" pitchFamily="34" charset="0"/>
                           <a:ea typeface="Arial" pitchFamily="34" charset="-122"/>
                           <a:cs typeface="Arial" pitchFamily="34" charset="-120"/>
                         </a:rPr>
-                        <a:t>8</a:t>
+                        <a:t>5</a:t>
                       </a:r>
-                      <a:endParaRPr lang="en-US" sz="1150" dirty="0">
+                      <a:endParaRPr lang="en-US" sz="1100" dirty="0">
                         <a:latin typeface="Arial" charset="0"/>
                         <a:ea typeface="Arial" charset="0"/>
                         <a:cs typeface="Arial" charset="0"/>
@@ -37892,7 +37892,7 @@
                       <a:tailEnd type="none" w="med" len="med"/>
                     </a:lnB>
                     <a:solidFill>
-                      <a:srgbClr val="FFFFFF"/>
+                      <a:srgbClr val="FFF2DC"/>
                     </a:solidFill>
                   </a:tcPr>
                 </a:tc>
@@ -37905,17 +37905,17 @@
                         <a:buNone/>
                       </a:pPr>
                       <a:r>
-                        <a:rPr lang="en-US" sz="1150" dirty="0">
+                        <a:rPr lang="en-US" sz="1100" b="1" dirty="0">
                           <a:solidFill>
-                            <a:srgbClr val="1B2236"/>
+                            <a:srgbClr val="16264F"/>
                           </a:solidFill>
                           <a:latin typeface="Arial" pitchFamily="34" charset="0"/>
                           <a:ea typeface="Arial" pitchFamily="34" charset="-122"/>
                           <a:cs typeface="Arial" pitchFamily="34" charset="-120"/>
                         </a:rPr>
-                        <a:t>2</a:t>
+                        <a:t>23</a:t>
                       </a:r>
-                      <a:endParaRPr lang="en-US" sz="1150" dirty="0">
+                      <a:endParaRPr lang="en-US" sz="1100" dirty="0">
                         <a:latin typeface="Arial" charset="0"/>
                         <a:ea typeface="Arial" charset="0"/>
                         <a:cs typeface="Arial" charset="0"/>
@@ -37960,12 +37960,12 @@
                       <a:tailEnd type="none" w="med" len="med"/>
                     </a:lnB>
                     <a:solidFill>
-                      <a:srgbClr val="FFFFFF"/>
+                      <a:srgbClr val="FFF2DC"/>
                     </a:solidFill>
                   </a:tcPr>
                 </a:tc>
               </a:tr>
-              <a:tr h="283464">
+              <a:tr h="246888">
                 <a:tc>
                   <a:txBody>
                     <a:bodyPr/>
@@ -37975,17 +37975,17 @@
                         <a:buNone/>
                       </a:pPr>
                       <a:r>
-                        <a:rPr lang="en-US" sz="1150" dirty="0">
+                        <a:rPr lang="en-US" sz="1100" b="1" dirty="0">
                           <a:solidFill>
-                            <a:srgbClr val="1B2236"/>
+                            <a:srgbClr val="16264F"/>
                           </a:solidFill>
                           <a:latin typeface="Arial" pitchFamily="34" charset="0"/>
                           <a:ea typeface="Arial" pitchFamily="34" charset="-122"/>
                           <a:cs typeface="Arial" pitchFamily="34" charset="-120"/>
                         </a:rPr>
-                        <a:t>سایر کلاس‌ها</a:t>
+                        <a:t>Stealing — دزدی</a:t>
                       </a:r>
-                      <a:endParaRPr lang="en-US" sz="1150" dirty="0">
+                      <a:endParaRPr lang="en-US" sz="1100" dirty="0">
                         <a:latin typeface="Arial" charset="0"/>
                         <a:ea typeface="Arial" charset="0"/>
                         <a:cs typeface="Arial" charset="0"/>
@@ -38030,7 +38030,7 @@
                       <a:tailEnd type="none" w="med" len="med"/>
                     </a:lnB>
                     <a:solidFill>
-                      <a:srgbClr val="EDF1F8"/>
+                      <a:srgbClr val="FFF2DC"/>
                     </a:solidFill>
                   </a:tcPr>
                 </a:tc>
@@ -38043,17 +38043,17 @@
                         <a:buNone/>
                       </a:pPr>
                       <a:r>
-                        <a:rPr lang="en-US" sz="1150" dirty="0">
+                        <a:rPr lang="en-US" sz="1100" b="1" dirty="0">
                           <a:solidFill>
-                            <a:srgbClr val="1B2236"/>
+                            <a:srgbClr val="16264F"/>
                           </a:solidFill>
                           <a:latin typeface="Arial" pitchFamily="34" charset="0"/>
                           <a:ea typeface="Arial" pitchFamily="34" charset="-122"/>
                           <a:cs typeface="Arial" pitchFamily="34" charset="-120"/>
                         </a:rPr>
-                        <a:t>8 هرکدام</a:t>
+                        <a:t>5</a:t>
                       </a:r>
-                      <a:endParaRPr lang="en-US" sz="1150" dirty="0">
+                      <a:endParaRPr lang="en-US" sz="1100" dirty="0">
                         <a:latin typeface="Arial" charset="0"/>
                         <a:ea typeface="Arial" charset="0"/>
                         <a:cs typeface="Arial" charset="0"/>
@@ -38098,7 +38098,7 @@
                       <a:tailEnd type="none" w="med" len="med"/>
                     </a:lnB>
                     <a:solidFill>
-                      <a:srgbClr val="EDF1F8"/>
+                      <a:srgbClr val="FFF2DC"/>
                     </a:solidFill>
                   </a:tcPr>
                 </a:tc>
@@ -38111,17 +38111,17 @@
                         <a:buNone/>
                       </a:pPr>
                       <a:r>
-                        <a:rPr lang="en-US" sz="1150" dirty="0">
+                        <a:rPr lang="en-US" sz="1100" b="1" dirty="0">
                           <a:solidFill>
-                            <a:srgbClr val="1B2236"/>
+                            <a:srgbClr val="16264F"/>
                           </a:solidFill>
                           <a:latin typeface="Arial" pitchFamily="34" charset="0"/>
                           <a:ea typeface="Arial" pitchFamily="34" charset="-122"/>
                           <a:cs typeface="Arial" pitchFamily="34" charset="-120"/>
                         </a:rPr>
-                        <a:t>≈ 5</a:t>
+                        <a:t>15</a:t>
                       </a:r>
-                      <a:endParaRPr lang="en-US" sz="1150" dirty="0">
+                      <a:endParaRPr lang="en-US" sz="1100" dirty="0">
                         <a:latin typeface="Arial" charset="0"/>
                         <a:ea typeface="Arial" charset="0"/>
                         <a:cs typeface="Arial" charset="0"/>
@@ -38166,7 +38166,625 @@
                       <a:tailEnd type="none" w="med" len="med"/>
                     </a:lnB>
                     <a:solidFill>
-                      <a:srgbClr val="EDF1F8"/>
+                      <a:srgbClr val="FFF2DC"/>
+                    </a:solidFill>
+                  </a:tcPr>
+                </a:tc>
+              </a:tr>
+              <a:tr h="246888">
+                <a:tc>
+                  <a:txBody>
+                    <a:bodyPr/>
+                    <a:lstStyle/>
+                    <a:p>
+                      <a:pPr algn="r" indent="0" marL="0">
+                        <a:buNone/>
+                      </a:pPr>
+                      <a:r>
+                        <a:rPr lang="en-US" sz="1100" b="1" dirty="0">
+                          <a:solidFill>
+                            <a:srgbClr val="16264F"/>
+                          </a:solidFill>
+                          <a:latin typeface="Arial" pitchFamily="34" charset="0"/>
+                          <a:ea typeface="Arial" pitchFamily="34" charset="-122"/>
+                          <a:cs typeface="Arial" pitchFamily="34" charset="-120"/>
+                        </a:rPr>
+                        <a:t>Vandalism — تخریب اموال</a:t>
+                      </a:r>
+                      <a:endParaRPr lang="en-US" sz="1100" dirty="0">
+                        <a:latin typeface="Arial" charset="0"/>
+                        <a:ea typeface="Arial" charset="0"/>
+                        <a:cs typeface="Arial" charset="0"/>
+                      </a:endParaRPr>
+                    </a:p>
+                  </a:txBody>
+                  <a:tcPr marL="38100" marR="38100" marT="38100" marB="38100" anchor="ctr">
+                    <a:lnL w="6350" cap="flat" cmpd="sng" algn="ctr">
+                      <a:solidFill>
+                        <a:srgbClr val="D9E0EC"/>
+                      </a:solidFill>
+                      <a:prstDash val="solid"/>
+                      <a:round/>
+                      <a:headEnd type="none" w="med" len="med"/>
+                      <a:tailEnd type="none" w="med" len="med"/>
+                    </a:lnL>
+                    <a:lnR w="6350" cap="flat" cmpd="sng" algn="ctr">
+                      <a:solidFill>
+                        <a:srgbClr val="D9E0EC"/>
+                      </a:solidFill>
+                      <a:prstDash val="solid"/>
+                      <a:round/>
+                      <a:headEnd type="none" w="med" len="med"/>
+                      <a:tailEnd type="none" w="med" len="med"/>
+                    </a:lnR>
+                    <a:lnT w="6350" cap="flat" cmpd="sng" algn="ctr">
+                      <a:solidFill>
+                        <a:srgbClr val="D9E0EC"/>
+                      </a:solidFill>
+                      <a:prstDash val="solid"/>
+                      <a:round/>
+                      <a:headEnd type="none" w="med" len="med"/>
+                      <a:tailEnd type="none" w="med" len="med"/>
+                    </a:lnT>
+                    <a:lnB w="6350" cap="flat" cmpd="sng" algn="ctr">
+                      <a:solidFill>
+                        <a:srgbClr val="D9E0EC"/>
+                      </a:solidFill>
+                      <a:prstDash val="solid"/>
+                      <a:round/>
+                      <a:headEnd type="none" w="med" len="med"/>
+                      <a:tailEnd type="none" w="med" len="med"/>
+                    </a:lnB>
+                    <a:solidFill>
+                      <a:srgbClr val="FFF2DC"/>
+                    </a:solidFill>
+                  </a:tcPr>
+                </a:tc>
+                <a:tc>
+                  <a:txBody>
+                    <a:bodyPr/>
+                    <a:lstStyle/>
+                    <a:p>
+                      <a:pPr algn="ctr" indent="0" marL="0">
+                        <a:buNone/>
+                      </a:pPr>
+                      <a:r>
+                        <a:rPr lang="en-US" sz="1100" b="1" dirty="0">
+                          <a:solidFill>
+                            <a:srgbClr val="16264F"/>
+                          </a:solidFill>
+                          <a:latin typeface="Arial" pitchFamily="34" charset="0"/>
+                          <a:ea typeface="Arial" pitchFamily="34" charset="-122"/>
+                          <a:cs typeface="Arial" pitchFamily="34" charset="-120"/>
+                        </a:rPr>
+                        <a:t>4</a:t>
+                      </a:r>
+                      <a:endParaRPr lang="en-US" sz="1100" dirty="0">
+                        <a:latin typeface="Arial" charset="0"/>
+                        <a:ea typeface="Arial" charset="0"/>
+                        <a:cs typeface="Arial" charset="0"/>
+                      </a:endParaRPr>
+                    </a:p>
+                  </a:txBody>
+                  <a:tcPr marL="38100" marR="38100" marT="38100" marB="38100" anchor="ctr">
+                    <a:lnL w="6350" cap="flat" cmpd="sng" algn="ctr">
+                      <a:solidFill>
+                        <a:srgbClr val="D9E0EC"/>
+                      </a:solidFill>
+                      <a:prstDash val="solid"/>
+                      <a:round/>
+                      <a:headEnd type="none" w="med" len="med"/>
+                      <a:tailEnd type="none" w="med" len="med"/>
+                    </a:lnL>
+                    <a:lnR w="6350" cap="flat" cmpd="sng" algn="ctr">
+                      <a:solidFill>
+                        <a:srgbClr val="D9E0EC"/>
+                      </a:solidFill>
+                      <a:prstDash val="solid"/>
+                      <a:round/>
+                      <a:headEnd type="none" w="med" len="med"/>
+                      <a:tailEnd type="none" w="med" len="med"/>
+                    </a:lnR>
+                    <a:lnT w="6350" cap="flat" cmpd="sng" algn="ctr">
+                      <a:solidFill>
+                        <a:srgbClr val="D9E0EC"/>
+                      </a:solidFill>
+                      <a:prstDash val="solid"/>
+                      <a:round/>
+                      <a:headEnd type="none" w="med" len="med"/>
+                      <a:tailEnd type="none" w="med" len="med"/>
+                    </a:lnT>
+                    <a:lnB w="6350" cap="flat" cmpd="sng" algn="ctr">
+                      <a:solidFill>
+                        <a:srgbClr val="D9E0EC"/>
+                      </a:solidFill>
+                      <a:prstDash val="solid"/>
+                      <a:round/>
+                      <a:headEnd type="none" w="med" len="med"/>
+                      <a:tailEnd type="none" w="med" len="med"/>
+                    </a:lnB>
+                    <a:solidFill>
+                      <a:srgbClr val="FFF2DC"/>
+                    </a:solidFill>
+                  </a:tcPr>
+                </a:tc>
+                <a:tc>
+                  <a:txBody>
+                    <a:bodyPr/>
+                    <a:lstStyle/>
+                    <a:p>
+                      <a:pPr algn="ctr" indent="0" marL="0">
+                        <a:buNone/>
+                      </a:pPr>
+                      <a:r>
+                        <a:rPr lang="en-US" sz="1100" b="1" dirty="0">
+                          <a:solidFill>
+                            <a:srgbClr val="16264F"/>
+                          </a:solidFill>
+                          <a:latin typeface="Arial" pitchFamily="34" charset="0"/>
+                          <a:ea typeface="Arial" pitchFamily="34" charset="-122"/>
+                          <a:cs typeface="Arial" pitchFamily="34" charset="-120"/>
+                        </a:rPr>
+                        <a:t>8</a:t>
+                      </a:r>
+                      <a:endParaRPr lang="en-US" sz="1100" dirty="0">
+                        <a:latin typeface="Arial" charset="0"/>
+                        <a:ea typeface="Arial" charset="0"/>
+                        <a:cs typeface="Arial" charset="0"/>
+                      </a:endParaRPr>
+                    </a:p>
+                  </a:txBody>
+                  <a:tcPr marL="38100" marR="38100" marT="38100" marB="38100" anchor="ctr">
+                    <a:lnL w="6350" cap="flat" cmpd="sng" algn="ctr">
+                      <a:solidFill>
+                        <a:srgbClr val="D9E0EC"/>
+                      </a:solidFill>
+                      <a:prstDash val="solid"/>
+                      <a:round/>
+                      <a:headEnd type="none" w="med" len="med"/>
+                      <a:tailEnd type="none" w="med" len="med"/>
+                    </a:lnL>
+                    <a:lnR w="6350" cap="flat" cmpd="sng" algn="ctr">
+                      <a:solidFill>
+                        <a:srgbClr val="D9E0EC"/>
+                      </a:solidFill>
+                      <a:prstDash val="solid"/>
+                      <a:round/>
+                      <a:headEnd type="none" w="med" len="med"/>
+                      <a:tailEnd type="none" w="med" len="med"/>
+                    </a:lnR>
+                    <a:lnT w="6350" cap="flat" cmpd="sng" algn="ctr">
+                      <a:solidFill>
+                        <a:srgbClr val="D9E0EC"/>
+                      </a:solidFill>
+                      <a:prstDash val="solid"/>
+                      <a:round/>
+                      <a:headEnd type="none" w="med" len="med"/>
+                      <a:tailEnd type="none" w="med" len="med"/>
+                    </a:lnT>
+                    <a:lnB w="6350" cap="flat" cmpd="sng" algn="ctr">
+                      <a:solidFill>
+                        <a:srgbClr val="D9E0EC"/>
+                      </a:solidFill>
+                      <a:prstDash val="solid"/>
+                      <a:round/>
+                      <a:headEnd type="none" w="med" len="med"/>
+                      <a:tailEnd type="none" w="med" len="med"/>
+                    </a:lnB>
+                    <a:solidFill>
+                      <a:srgbClr val="FFF2DC"/>
+                    </a:solidFill>
+                  </a:tcPr>
+                </a:tc>
+              </a:tr>
+              <a:tr h="246888">
+                <a:tc>
+                  <a:txBody>
+                    <a:bodyPr/>
+                    <a:lstStyle/>
+                    <a:p>
+                      <a:pPr algn="r" indent="0" marL="0">
+                        <a:buNone/>
+                      </a:pPr>
+                      <a:r>
+                        <a:rPr lang="en-US" sz="1100" b="1" dirty="0">
+                          <a:solidFill>
+                            <a:srgbClr val="16264F"/>
+                          </a:solidFill>
+                          <a:latin typeface="Arial" pitchFamily="34" charset="0"/>
+                          <a:ea typeface="Arial" pitchFamily="34" charset="-122"/>
+                          <a:cs typeface="Arial" pitchFamily="34" charset="-120"/>
+                        </a:rPr>
+                        <a:t>Abuse — سوءاستفاده</a:t>
+                      </a:r>
+                      <a:endParaRPr lang="en-US" sz="1100" dirty="0">
+                        <a:latin typeface="Arial" charset="0"/>
+                        <a:ea typeface="Arial" charset="0"/>
+                        <a:cs typeface="Arial" charset="0"/>
+                      </a:endParaRPr>
+                    </a:p>
+                  </a:txBody>
+                  <a:tcPr marL="38100" marR="38100" marT="38100" marB="38100" anchor="ctr">
+                    <a:lnL w="6350" cap="flat" cmpd="sng" algn="ctr">
+                      <a:solidFill>
+                        <a:srgbClr val="D9E0EC"/>
+                      </a:solidFill>
+                      <a:prstDash val="solid"/>
+                      <a:round/>
+                      <a:headEnd type="none" w="med" len="med"/>
+                      <a:tailEnd type="none" w="med" len="med"/>
+                    </a:lnL>
+                    <a:lnR w="6350" cap="flat" cmpd="sng" algn="ctr">
+                      <a:solidFill>
+                        <a:srgbClr val="D9E0EC"/>
+                      </a:solidFill>
+                      <a:prstDash val="solid"/>
+                      <a:round/>
+                      <a:headEnd type="none" w="med" len="med"/>
+                      <a:tailEnd type="none" w="med" len="med"/>
+                    </a:lnR>
+                    <a:lnT w="6350" cap="flat" cmpd="sng" algn="ctr">
+                      <a:solidFill>
+                        <a:srgbClr val="D9E0EC"/>
+                      </a:solidFill>
+                      <a:prstDash val="solid"/>
+                      <a:round/>
+                      <a:headEnd type="none" w="med" len="med"/>
+                      <a:tailEnd type="none" w="med" len="med"/>
+                    </a:lnT>
+                    <a:lnB w="6350" cap="flat" cmpd="sng" algn="ctr">
+                      <a:solidFill>
+                        <a:srgbClr val="D9E0EC"/>
+                      </a:solidFill>
+                      <a:prstDash val="solid"/>
+                      <a:round/>
+                      <a:headEnd type="none" w="med" len="med"/>
+                      <a:tailEnd type="none" w="med" len="med"/>
+                    </a:lnB>
+                    <a:solidFill>
+                      <a:srgbClr val="FFF2DC"/>
+                    </a:solidFill>
+                  </a:tcPr>
+                </a:tc>
+                <a:tc>
+                  <a:txBody>
+                    <a:bodyPr/>
+                    <a:lstStyle/>
+                    <a:p>
+                      <a:pPr algn="ctr" indent="0" marL="0">
+                        <a:buNone/>
+                      </a:pPr>
+                      <a:r>
+                        <a:rPr lang="en-US" sz="1100" b="1" dirty="0">
+                          <a:solidFill>
+                            <a:srgbClr val="16264F"/>
+                          </a:solidFill>
+                          <a:latin typeface="Arial" pitchFamily="34" charset="0"/>
+                          <a:ea typeface="Arial" pitchFamily="34" charset="-122"/>
+                          <a:cs typeface="Arial" pitchFamily="34" charset="-120"/>
+                        </a:rPr>
+                        <a:t>3</a:t>
+                      </a:r>
+                      <a:endParaRPr lang="en-US" sz="1100" dirty="0">
+                        <a:latin typeface="Arial" charset="0"/>
+                        <a:ea typeface="Arial" charset="0"/>
+                        <a:cs typeface="Arial" charset="0"/>
+                      </a:endParaRPr>
+                    </a:p>
+                  </a:txBody>
+                  <a:tcPr marL="38100" marR="38100" marT="38100" marB="38100" anchor="ctr">
+                    <a:lnL w="6350" cap="flat" cmpd="sng" algn="ctr">
+                      <a:solidFill>
+                        <a:srgbClr val="D9E0EC"/>
+                      </a:solidFill>
+                      <a:prstDash val="solid"/>
+                      <a:round/>
+                      <a:headEnd type="none" w="med" len="med"/>
+                      <a:tailEnd type="none" w="med" len="med"/>
+                    </a:lnL>
+                    <a:lnR w="6350" cap="flat" cmpd="sng" algn="ctr">
+                      <a:solidFill>
+                        <a:srgbClr val="D9E0EC"/>
+                      </a:solidFill>
+                      <a:prstDash val="solid"/>
+                      <a:round/>
+                      <a:headEnd type="none" w="med" len="med"/>
+                      <a:tailEnd type="none" w="med" len="med"/>
+                    </a:lnR>
+                    <a:lnT w="6350" cap="flat" cmpd="sng" algn="ctr">
+                      <a:solidFill>
+                        <a:srgbClr val="D9E0EC"/>
+                      </a:solidFill>
+                      <a:prstDash val="solid"/>
+                      <a:round/>
+                      <a:headEnd type="none" w="med" len="med"/>
+                      <a:tailEnd type="none" w="med" len="med"/>
+                    </a:lnT>
+                    <a:lnB w="6350" cap="flat" cmpd="sng" algn="ctr">
+                      <a:solidFill>
+                        <a:srgbClr val="D9E0EC"/>
+                      </a:solidFill>
+                      <a:prstDash val="solid"/>
+                      <a:round/>
+                      <a:headEnd type="none" w="med" len="med"/>
+                      <a:tailEnd type="none" w="med" len="med"/>
+                    </a:lnB>
+                    <a:solidFill>
+                      <a:srgbClr val="FFF2DC"/>
+                    </a:solidFill>
+                  </a:tcPr>
+                </a:tc>
+                <a:tc>
+                  <a:txBody>
+                    <a:bodyPr/>
+                    <a:lstStyle/>
+                    <a:p>
+                      <a:pPr algn="ctr" indent="0" marL="0">
+                        <a:buNone/>
+                      </a:pPr>
+                      <a:r>
+                        <a:rPr lang="en-US" sz="1100" b="1" dirty="0">
+                          <a:solidFill>
+                            <a:srgbClr val="16264F"/>
+                          </a:solidFill>
+                          <a:latin typeface="Arial" pitchFamily="34" charset="0"/>
+                          <a:ea typeface="Arial" pitchFamily="34" charset="-122"/>
+                          <a:cs typeface="Arial" pitchFamily="34" charset="-120"/>
+                        </a:rPr>
+                        <a:t>8</a:t>
+                      </a:r>
+                      <a:endParaRPr lang="en-US" sz="1100" dirty="0">
+                        <a:latin typeface="Arial" charset="0"/>
+                        <a:ea typeface="Arial" charset="0"/>
+                        <a:cs typeface="Arial" charset="0"/>
+                      </a:endParaRPr>
+                    </a:p>
+                  </a:txBody>
+                  <a:tcPr marL="38100" marR="38100" marT="38100" marB="38100" anchor="ctr">
+                    <a:lnL w="6350" cap="flat" cmpd="sng" algn="ctr">
+                      <a:solidFill>
+                        <a:srgbClr val="D9E0EC"/>
+                      </a:solidFill>
+                      <a:prstDash val="solid"/>
+                      <a:round/>
+                      <a:headEnd type="none" w="med" len="med"/>
+                      <a:tailEnd type="none" w="med" len="med"/>
+                    </a:lnL>
+                    <a:lnR w="6350" cap="flat" cmpd="sng" algn="ctr">
+                      <a:solidFill>
+                        <a:srgbClr val="D9E0EC"/>
+                      </a:solidFill>
+                      <a:prstDash val="solid"/>
+                      <a:round/>
+                      <a:headEnd type="none" w="med" len="med"/>
+                      <a:tailEnd type="none" w="med" len="med"/>
+                    </a:lnR>
+                    <a:lnT w="6350" cap="flat" cmpd="sng" algn="ctr">
+                      <a:solidFill>
+                        <a:srgbClr val="D9E0EC"/>
+                      </a:solidFill>
+                      <a:prstDash val="solid"/>
+                      <a:round/>
+                      <a:headEnd type="none" w="med" len="med"/>
+                      <a:tailEnd type="none" w="med" len="med"/>
+                    </a:lnT>
+                    <a:lnB w="6350" cap="flat" cmpd="sng" algn="ctr">
+                      <a:solidFill>
+                        <a:srgbClr val="D9E0EC"/>
+                      </a:solidFill>
+                      <a:prstDash val="solid"/>
+                      <a:round/>
+                      <a:headEnd type="none" w="med" len="med"/>
+                      <a:tailEnd type="none" w="med" len="med"/>
+                    </a:lnB>
+                    <a:solidFill>
+                      <a:srgbClr val="FFF2DC"/>
+                    </a:solidFill>
+                  </a:tcPr>
+                </a:tc>
+              </a:tr>
+              <a:tr h="246888">
+                <a:tc>
+                  <a:txBody>
+                    <a:bodyPr/>
+                    <a:lstStyle/>
+                    <a:p>
+                      <a:pPr algn="r" indent="0" marL="0">
+                        <a:buNone/>
+                      </a:pPr>
+                      <a:r>
+                        <a:rPr lang="en-US" sz="1100" b="1" dirty="0">
+                          <a:solidFill>
+                            <a:srgbClr val="16264F"/>
+                          </a:solidFill>
+                          <a:latin typeface="Arial" pitchFamily="34" charset="0"/>
+                          <a:ea typeface="Arial" pitchFamily="34" charset="-122"/>
+                          <a:cs typeface="Arial" pitchFamily="34" charset="-120"/>
+                        </a:rPr>
+                        <a:t>Assault — تعرض</a:t>
+                      </a:r>
+                      <a:endParaRPr lang="en-US" sz="1100" dirty="0">
+                        <a:latin typeface="Arial" charset="0"/>
+                        <a:ea typeface="Arial" charset="0"/>
+                        <a:cs typeface="Arial" charset="0"/>
+                      </a:endParaRPr>
+                    </a:p>
+                  </a:txBody>
+                  <a:tcPr marL="38100" marR="38100" marT="38100" marB="38100" anchor="ctr">
+                    <a:lnL w="6350" cap="flat" cmpd="sng" algn="ctr">
+                      <a:solidFill>
+                        <a:srgbClr val="D9E0EC"/>
+                      </a:solidFill>
+                      <a:prstDash val="solid"/>
+                      <a:round/>
+                      <a:headEnd type="none" w="med" len="med"/>
+                      <a:tailEnd type="none" w="med" len="med"/>
+                    </a:lnL>
+                    <a:lnR w="6350" cap="flat" cmpd="sng" algn="ctr">
+                      <a:solidFill>
+                        <a:srgbClr val="D9E0EC"/>
+                      </a:solidFill>
+                      <a:prstDash val="solid"/>
+                      <a:round/>
+                      <a:headEnd type="none" w="med" len="med"/>
+                      <a:tailEnd type="none" w="med" len="med"/>
+                    </a:lnR>
+                    <a:lnT w="6350" cap="flat" cmpd="sng" algn="ctr">
+                      <a:solidFill>
+                        <a:srgbClr val="D9E0EC"/>
+                      </a:solidFill>
+                      <a:prstDash val="solid"/>
+                      <a:round/>
+                      <a:headEnd type="none" w="med" len="med"/>
+                      <a:tailEnd type="none" w="med" len="med"/>
+                    </a:lnT>
+                    <a:lnB w="6350" cap="flat" cmpd="sng" algn="ctr">
+                      <a:solidFill>
+                        <a:srgbClr val="D9E0EC"/>
+                      </a:solidFill>
+                      <a:prstDash val="solid"/>
+                      <a:round/>
+                      <a:headEnd type="none" w="med" len="med"/>
+                      <a:tailEnd type="none" w="med" len="med"/>
+                    </a:lnB>
+                    <a:solidFill>
+                      <a:srgbClr val="FFF2DC"/>
+                    </a:solidFill>
+                  </a:tcPr>
+                </a:tc>
+                <a:tc>
+                  <a:txBody>
+                    <a:bodyPr/>
+                    <a:lstStyle/>
+                    <a:p>
+                      <a:pPr algn="ctr" indent="0" marL="0">
+                        <a:buNone/>
+                      </a:pPr>
+                      <a:r>
+                        <a:rPr lang="en-US" sz="1100" b="1" dirty="0">
+                          <a:solidFill>
+                            <a:srgbClr val="16264F"/>
+                          </a:solidFill>
+                          <a:latin typeface="Arial" pitchFamily="34" charset="0"/>
+                          <a:ea typeface="Arial" pitchFamily="34" charset="-122"/>
+                          <a:cs typeface="Arial" pitchFamily="34" charset="-120"/>
+                        </a:rPr>
+                        <a:t>3</a:t>
+                      </a:r>
+                      <a:endParaRPr lang="en-US" sz="1100" dirty="0">
+                        <a:latin typeface="Arial" charset="0"/>
+                        <a:ea typeface="Arial" charset="0"/>
+                        <a:cs typeface="Arial" charset="0"/>
+                      </a:endParaRPr>
+                    </a:p>
+                  </a:txBody>
+                  <a:tcPr marL="38100" marR="38100" marT="38100" marB="38100" anchor="ctr">
+                    <a:lnL w="6350" cap="flat" cmpd="sng" algn="ctr">
+                      <a:solidFill>
+                        <a:srgbClr val="D9E0EC"/>
+                      </a:solidFill>
+                      <a:prstDash val="solid"/>
+                      <a:round/>
+                      <a:headEnd type="none" w="med" len="med"/>
+                      <a:tailEnd type="none" w="med" len="med"/>
+                    </a:lnL>
+                    <a:lnR w="6350" cap="flat" cmpd="sng" algn="ctr">
+                      <a:solidFill>
+                        <a:srgbClr val="D9E0EC"/>
+                      </a:solidFill>
+                      <a:prstDash val="solid"/>
+                      <a:round/>
+                      <a:headEnd type="none" w="med" len="med"/>
+                      <a:tailEnd type="none" w="med" len="med"/>
+                    </a:lnR>
+                    <a:lnT w="6350" cap="flat" cmpd="sng" algn="ctr">
+                      <a:solidFill>
+                        <a:srgbClr val="D9E0EC"/>
+                      </a:solidFill>
+                      <a:prstDash val="solid"/>
+                      <a:round/>
+                      <a:headEnd type="none" w="med" len="med"/>
+                      <a:tailEnd type="none" w="med" len="med"/>
+                    </a:lnT>
+                    <a:lnB w="6350" cap="flat" cmpd="sng" algn="ctr">
+                      <a:solidFill>
+                        <a:srgbClr val="D9E0EC"/>
+                      </a:solidFill>
+                      <a:prstDash val="solid"/>
+                      <a:round/>
+                      <a:headEnd type="none" w="med" len="med"/>
+                      <a:tailEnd type="none" w="med" len="med"/>
+                    </a:lnB>
+                    <a:solidFill>
+                      <a:srgbClr val="FFF2DC"/>
+                    </a:solidFill>
+                  </a:tcPr>
+                </a:tc>
+                <a:tc>
+                  <a:txBody>
+                    <a:bodyPr/>
+                    <a:lstStyle/>
+                    <a:p>
+                      <a:pPr algn="ctr" indent="0" marL="0">
+                        <a:buNone/>
+                      </a:pPr>
+                      <a:r>
+                        <a:rPr lang="en-US" sz="1100" b="1" dirty="0">
+                          <a:solidFill>
+                            <a:srgbClr val="16264F"/>
+                          </a:solidFill>
+                          <a:latin typeface="Arial" pitchFamily="34" charset="0"/>
+                          <a:ea typeface="Arial" pitchFamily="34" charset="-122"/>
+                          <a:cs typeface="Arial" pitchFamily="34" charset="-120"/>
+                        </a:rPr>
+                        <a:t>8</a:t>
+                      </a:r>
+                      <a:endParaRPr lang="en-US" sz="1100" dirty="0">
+                        <a:latin typeface="Arial" charset="0"/>
+                        <a:ea typeface="Arial" charset="0"/>
+                        <a:cs typeface="Arial" charset="0"/>
+                      </a:endParaRPr>
+                    </a:p>
+                  </a:txBody>
+                  <a:tcPr marL="38100" marR="38100" marT="38100" marB="38100" anchor="ctr">
+                    <a:lnL w="6350" cap="flat" cmpd="sng" algn="ctr">
+                      <a:solidFill>
+                        <a:srgbClr val="D9E0EC"/>
+                      </a:solidFill>
+                      <a:prstDash val="solid"/>
+                      <a:round/>
+                      <a:headEnd type="none" w="med" len="med"/>
+                      <a:tailEnd type="none" w="med" len="med"/>
+                    </a:lnL>
+                    <a:lnR w="6350" cap="flat" cmpd="sng" algn="ctr">
+                      <a:solidFill>
+                        <a:srgbClr val="D9E0EC"/>
+                      </a:solidFill>
+                      <a:prstDash val="solid"/>
+                      <a:round/>
+                      <a:headEnd type="none" w="med" len="med"/>
+                      <a:tailEnd type="none" w="med" len="med"/>
+                    </a:lnR>
+                    <a:lnT w="6350" cap="flat" cmpd="sng" algn="ctr">
+                      <a:solidFill>
+                        <a:srgbClr val="D9E0EC"/>
+                      </a:solidFill>
+                      <a:prstDash val="solid"/>
+                      <a:round/>
+                      <a:headEnd type="none" w="med" len="med"/>
+                      <a:tailEnd type="none" w="med" len="med"/>
+                    </a:lnT>
+                    <a:lnB w="6350" cap="flat" cmpd="sng" algn="ctr">
+                      <a:solidFill>
+                        <a:srgbClr val="D9E0EC"/>
+                      </a:solidFill>
+                      <a:prstDash val="solid"/>
+                      <a:round/>
+                      <a:headEnd type="none" w="med" len="med"/>
+                      <a:tailEnd type="none" w="med" len="med"/>
+                    </a:lnB>
+                    <a:solidFill>
+                      <a:srgbClr val="FFF2DC"/>
                     </a:solidFill>
                   </a:tcPr>
                 </a:tc>
@@ -38177,18 +38795,60 @@
       </p:graphicFrame>
       <p:sp>
         <p:nvSpPr>
-          <p:cNvPr id="5" name="Shape 2"/>
+          <p:cNvPr id="5" name="Text 2"/>
+          <p:cNvSpPr txBox="1"/>
+          <p:nvPr/>
+        </p:nvSpPr>
+        <p:spPr>
+          <a:xfrm>
+            <a:off x="548640" y="5358384"/>
+            <a:ext cx="6766560" cy="365760"/>
+          </a:xfrm>
+          <a:prstGeom prst="rect">
+            <a:avLst/>
+          </a:prstGeom>
+          <a:noFill/>
+          <a:ln/>
+        </p:spPr>
+        <p:txBody>
+          <a:bodyPr wrap="square" lIns="0" tIns="0" rIns="0" bIns="0" rtlCol="0" anchor="t"/>
+          <a:lstStyle/>
+          <a:p>
+            <a:pPr rtl="1" algn="r" indent="0" marL="0">
+              <a:lnSpc>
+                <a:spcPts val="1600"/>
+              </a:lnSpc>
+              <a:buNone/>
+            </a:pPr>
+            <a:r>
+              <a:rPr lang="en-US" sz="1100" dirty="0">
+                <a:solidFill>
+                  <a:srgbClr val="6A748C"/>
+                </a:solidFill>
+                <a:latin typeface="Arial" pitchFamily="34" charset="0"/>
+                <a:ea typeface="Arial" pitchFamily="34" charset="-122"/>
+                <a:cs typeface="Arial" pitchFamily="34" charset="-120"/>
+              </a:rPr>
+              <a:t>جمع ستون دوم ۲۹۰ و جمع ستون سوم ۲۹۶ است. ردیف‌های پررنگ، هفت کلاسی هستند که پنج ویدیوی آزمون یا کمتر دارند.</a:t>
+            </a:r>
+            <a:endParaRPr lang="en-US" sz="1100" dirty="0"/>
+          </a:p>
+        </p:txBody>
+      </p:sp>
+      <p:sp>
+        <p:nvSpPr>
+          <p:cNvPr id="6" name="Shape 3"/>
           <p:cNvSpPr/>
           <p:nvPr/>
         </p:nvSpPr>
         <p:spPr>
           <a:xfrm>
-            <a:off x="7589520" y="1600200"/>
-            <a:ext cx="4023360" cy="2194560"/>
+            <a:off x="7589520" y="1572768"/>
+            <a:ext cx="4023360" cy="1783080"/>
           </a:xfrm>
           <a:prstGeom prst="roundRect">
             <a:avLst>
-              <a:gd name="adj" fmla="val 4167"/>
+              <a:gd name="adj" fmla="val 5128"/>
             </a:avLst>
           </a:prstGeom>
           <a:solidFill>
@@ -38211,13 +38871,13 @@
       </p:sp>
       <p:sp>
         <p:nvSpPr>
-          <p:cNvPr id="6" name="Text 3"/>
+          <p:cNvPr id="7" name="Text 4"/>
           <p:cNvSpPr txBox="1"/>
           <p:nvPr/>
         </p:nvSpPr>
         <p:spPr>
           <a:xfrm>
-            <a:off x="7863840" y="1783080"/>
+            <a:off x="7863840" y="1737360"/>
             <a:ext cx="3474720" cy="320040"/>
           </a:xfrm>
           <a:prstGeom prst="rect">
@@ -38234,7 +38894,7 @@
               <a:buNone/>
             </a:pPr>
             <a:r>
-              <a:rPr lang="en-US" sz="1600" b="1" dirty="0">
+              <a:rPr lang="en-US" sz="1500" b="1" dirty="0">
                 <a:solidFill>
                   <a:srgbClr val="E8A33D"/>
                 </a:solidFill>
@@ -38244,20 +38904,20 @@
               </a:rPr>
               <a:t>دو تقسیم متفاوت</a:t>
             </a:r>
-            <a:endParaRPr lang="en-US" sz="1600" dirty="0"/>
+            <a:endParaRPr lang="en-US" sz="1500" dirty="0"/>
           </a:p>
         </p:txBody>
       </p:sp>
       <p:sp>
         <p:nvSpPr>
-          <p:cNvPr id="7" name="Text 4"/>
+          <p:cNvPr id="8" name="Text 5"/>
           <p:cNvSpPr txBox="1"/>
           <p:nvPr/>
         </p:nvSpPr>
         <p:spPr>
           <a:xfrm>
-            <a:off x="7863840" y="2194560"/>
-            <a:ext cx="3474720" cy="1463040"/>
+            <a:off x="7863840" y="2103120"/>
+            <a:ext cx="3474720" cy="1143000"/>
           </a:xfrm>
           <a:prstGeom prst="rect">
             <a:avLst/>
@@ -38271,12 +38931,12 @@
           <a:p>
             <a:pPr rtl="1" algn="r" indent="0" marL="0">
               <a:lnSpc>
-                <a:spcPts val="1900"/>
+                <a:spcPts val="1800"/>
               </a:lnSpc>
               <a:buNone/>
             </a:pPr>
             <a:r>
-              <a:rPr lang="en-US" sz="1200" dirty="0">
+              <a:rPr lang="en-US" sz="1150" dirty="0">
                 <a:solidFill>
                   <a:srgbClr val="1B2236"/>
                 </a:solidFill>
@@ -38284,26 +38944,26 @@
                 <a:ea typeface="Arial" pitchFamily="34" charset="-122"/>
                 <a:cs typeface="Arial" pitchFamily="34" charset="-120"/>
               </a:rPr>
-              <a:t>مسیر X-CLIP روی تقسیمی با ۲۹۶ ویدیوی آزمون اجرا شد و مسیر VideoMAE روی تقسیم استاندارد با ۲۹۰ ویدیو. به همین دلیل اعداد دو مسیر مستقیماً قابل جمع نیستند.</a:t>
+              <a:t>مسیر X-CLIP روی تقسیمی با ۲۹۶ ویدیوی آزمون اجرا شد و مسیر VideoMAE روی تقسیم استاندارد با ۲۹۰ ویدیو. اعداد دو مسیر با این قید خوانده شوند.</a:t>
             </a:r>
-            <a:endParaRPr lang="en-US" sz="1200" dirty="0"/>
+            <a:endParaRPr lang="en-US" sz="1150" dirty="0"/>
           </a:p>
         </p:txBody>
       </p:sp>
       <p:sp>
         <p:nvSpPr>
-          <p:cNvPr id="8" name="Shape 5"/>
+          <p:cNvPr id="9" name="Shape 6"/>
           <p:cNvSpPr/>
           <p:nvPr/>
         </p:nvSpPr>
         <p:spPr>
           <a:xfrm>
-            <a:off x="7589520" y="3977640"/>
-            <a:ext cx="4023360" cy="2103120"/>
+            <a:off x="7589520" y="3520440"/>
+            <a:ext cx="4023360" cy="1691640"/>
           </a:xfrm>
           <a:prstGeom prst="roundRect">
             <a:avLst>
-              <a:gd name="adj" fmla="val 4348"/>
+              <a:gd name="adj" fmla="val 5405"/>
             </a:avLst>
           </a:prstGeom>
           <a:solidFill>
@@ -38326,13 +38986,13 @@
       </p:sp>
       <p:sp>
         <p:nvSpPr>
-          <p:cNvPr id="9" name="Text 6"/>
+          <p:cNvPr id="10" name="Text 7"/>
           <p:cNvSpPr txBox="1"/>
           <p:nvPr/>
         </p:nvSpPr>
         <p:spPr>
           <a:xfrm>
-            <a:off x="7863840" y="4160520"/>
+            <a:off x="7863840" y="3685032"/>
             <a:ext cx="3474720" cy="320040"/>
           </a:xfrm>
           <a:prstGeom prst="rect">
@@ -38349,7 +39009,7 @@
               <a:buNone/>
             </a:pPr>
             <a:r>
-              <a:rPr lang="en-US" sz="1600" b="1" dirty="0">
+              <a:rPr lang="en-US" sz="1500" b="1" dirty="0">
                 <a:solidFill>
                   <a:srgbClr val="16264F"/>
                 </a:solidFill>
@@ -38359,20 +39019,20 @@
               </a:rPr>
               <a:t>چرا ارزیابی نوفه‌آلود است</a:t>
             </a:r>
-            <a:endParaRPr lang="en-US" sz="1600" dirty="0"/>
+            <a:endParaRPr lang="en-US" sz="1500" dirty="0"/>
           </a:p>
         </p:txBody>
       </p:sp>
       <p:sp>
         <p:nvSpPr>
-          <p:cNvPr id="10" name="Text 7"/>
+          <p:cNvPr id="11" name="Text 8"/>
           <p:cNvSpPr txBox="1"/>
           <p:nvPr/>
         </p:nvSpPr>
         <p:spPr>
           <a:xfrm>
-            <a:off x="7863840" y="4572000"/>
-            <a:ext cx="3474720" cy="1371600"/>
+            <a:off x="7863840" y="4050792"/>
+            <a:ext cx="3474720" cy="1097280"/>
           </a:xfrm>
           <a:prstGeom prst="rect">
             <a:avLst/>
@@ -38386,12 +39046,12 @@
           <a:p>
             <a:pPr rtl="1" algn="r" indent="0" marL="0">
               <a:lnSpc>
-                <a:spcPts val="1900"/>
+                <a:spcPts val="1800"/>
               </a:lnSpc>
               <a:buNone/>
             </a:pPr>
             <a:r>
-              <a:rPr lang="en-US" sz="1200" dirty="0">
+              <a:rPr lang="en-US" sz="1150" dirty="0">
                 <a:solidFill>
                   <a:srgbClr val="1B2236"/>
                 </a:solidFill>
@@ -38399,7 +39059,161 @@
                 <a:ea typeface="Arial" pitchFamily="34" charset="-122"/>
                 <a:cs typeface="Arial" pitchFamily="34" charset="-120"/>
               </a:rPr>
-              <a:t>با هشت ویدیو در یک کلاس، تغییر برچسب یک ویدیو ۱۲٫۵ درصد یادآوری آن کلاس را جابه‌جا می‌کند. ماکرو F1 به هر ۱۴ کلاس وزن یکسان می‌دهد.</a:t>
+              <a:t>کلاس Assault تنها سه ویدیوی آزمون دارد. یک ویدیو یعنی یک‌سوم یادآوری آن کلاس، و ماکرو F1 به هر ۱۴ کلاس وزن یکسان می‌دهد.</a:t>
+            </a:r>
+            <a:endParaRPr lang="en-US" sz="1150" dirty="0"/>
+          </a:p>
+        </p:txBody>
+      </p:sp>
+      <p:sp>
+        <p:nvSpPr>
+          <p:cNvPr id="12" name="Shape 9"/>
+          <p:cNvSpPr/>
+          <p:nvPr/>
+        </p:nvSpPr>
+        <p:spPr>
+          <a:xfrm>
+            <a:off x="7589520" y="5394960"/>
+            <a:ext cx="4023360" cy="960120"/>
+          </a:xfrm>
+          <a:prstGeom prst="roundRect">
+            <a:avLst>
+              <a:gd name="adj" fmla="val 9524"/>
+            </a:avLst>
+          </a:prstGeom>
+          <a:solidFill>
+            <a:srgbClr val="FDEEEC"/>
+          </a:solidFill>
+          <a:ln w="12700">
+            <a:solidFill>
+              <a:srgbClr val="E2E7F0"/>
+            </a:solidFill>
+            <a:prstDash val="solid"/>
+          </a:ln>
+          <a:effectLst>
+            <a:outerShdw sx="100000" sy="100000" kx="0" ky="0" algn="bl" rotWithShape="0" blurRad="101600" dist="25400" dir="5400000">
+              <a:srgbClr val="8A94AC">
+                <a:alpha val="16000"/>
+              </a:srgbClr>
+            </a:outerShdw>
+          </a:effectLst>
+        </p:spPr>
+      </p:sp>
+      <p:sp>
+        <p:nvSpPr>
+          <p:cNvPr id="13" name="Text 10"/>
+          <p:cNvSpPr txBox="1"/>
+          <p:nvPr/>
+        </p:nvSpPr>
+        <p:spPr>
+          <a:xfrm>
+            <a:off x="7863840" y="5559552"/>
+            <a:ext cx="3474720" cy="685800"/>
+          </a:xfrm>
+          <a:prstGeom prst="rect">
+            <a:avLst/>
+          </a:prstGeom>
+          <a:noFill/>
+          <a:ln/>
+        </p:spPr>
+        <p:txBody>
+          <a:bodyPr wrap="square" lIns="0" tIns="0" rIns="0" bIns="0" rtlCol="0" anchor="t"/>
+          <a:lstStyle/>
+          <a:p>
+            <a:pPr rtl="1" algn="r" indent="0" marL="0">
+              <a:lnSpc>
+                <a:spcPts val="1700"/>
+              </a:lnSpc>
+              <a:buNone/>
+            </a:pPr>
+            <a:r>
+              <a:rPr lang="en-US" sz="1100" dirty="0">
+                <a:solidFill>
+                  <a:srgbClr val="C9483B"/>
+                </a:solidFill>
+                <a:latin typeface="Arial" pitchFamily="34" charset="0"/>
+                <a:ea typeface="Arial" pitchFamily="34" charset="-122"/>
+                <a:cs typeface="Arial" pitchFamily="34" charset="-120"/>
+              </a:rPr>
+              <a:t>پیش از ارائه، این اعداد را با فایل تقسیم خودتان بسنجید؛ فرمان در سربرگ build_slides.js است.</a:t>
+            </a:r>
+            <a:endParaRPr lang="en-US" sz="1100" dirty="0"/>
+          </a:p>
+        </p:txBody>
+      </p:sp>
+      <p:sp>
+        <p:nvSpPr>
+          <p:cNvPr id="14" name="Text 11"/>
+          <p:cNvSpPr txBox="1"/>
+          <p:nvPr/>
+        </p:nvSpPr>
+        <p:spPr>
+          <a:xfrm>
+            <a:off x="548640" y="5669280"/>
+            <a:ext cx="2194560" cy="777240"/>
+          </a:xfrm>
+          <a:prstGeom prst="rect">
+            <a:avLst/>
+          </a:prstGeom>
+          <a:noFill/>
+          <a:ln/>
+        </p:spPr>
+        <p:txBody>
+          <a:bodyPr wrap="square" lIns="0" tIns="0" rIns="0" bIns="0" rtlCol="0" anchor="ctr"/>
+          <a:lstStyle/>
+          <a:p>
+            <a:pPr algn="ctr" indent="0" marL="0">
+              <a:buNone/>
+            </a:pPr>
+            <a:r>
+              <a:rPr lang="en-US" sz="4000" b="1" dirty="0">
+                <a:solidFill>
+                  <a:srgbClr val="16264F"/>
+                </a:solidFill>
+                <a:latin typeface="Arial" pitchFamily="34" charset="0"/>
+                <a:ea typeface="Arial" pitchFamily="34" charset="-122"/>
+                <a:cs typeface="Arial" pitchFamily="34" charset="-120"/>
+              </a:rPr>
+              <a:t>290</a:t>
+            </a:r>
+            <a:endParaRPr lang="en-US" sz="4000" dirty="0"/>
+          </a:p>
+        </p:txBody>
+      </p:sp>
+      <p:sp>
+        <p:nvSpPr>
+          <p:cNvPr id="15" name="Text 12"/>
+          <p:cNvSpPr txBox="1"/>
+          <p:nvPr/>
+        </p:nvSpPr>
+        <p:spPr>
+          <a:xfrm>
+            <a:off x="548640" y="6419088"/>
+            <a:ext cx="2194560" cy="457200"/>
+          </a:xfrm>
+          <a:prstGeom prst="rect">
+            <a:avLst/>
+          </a:prstGeom>
+          <a:noFill/>
+          <a:ln/>
+        </p:spPr>
+        <p:txBody>
+          <a:bodyPr wrap="square" lIns="0" tIns="0" rIns="0" bIns="0" rtlCol="0" anchor="t"/>
+          <a:lstStyle/>
+          <a:p>
+            <a:pPr rtl="1" algn="ctr" indent="0" marL="0">
+              <a:buNone/>
+            </a:pPr>
+            <a:r>
+              <a:rPr lang="en-US" sz="1200" dirty="0">
+                <a:solidFill>
+                  <a:srgbClr val="6A748C"/>
+                </a:solidFill>
+                <a:latin typeface="Arial" pitchFamily="34" charset="0"/>
+                <a:ea typeface="Arial" pitchFamily="34" charset="-122"/>
+                <a:cs typeface="Arial" pitchFamily="34" charset="-120"/>
+              </a:rPr>
+              <a:t>کل مجموعه آزمون</a:t>
             </a:r>
             <a:endParaRPr lang="en-US" sz="1200" dirty="0"/>
           </a:p>
@@ -38407,13 +39221,13 @@
       </p:sp>
       <p:sp>
         <p:nvSpPr>
-          <p:cNvPr id="11" name="Text 8"/>
+          <p:cNvPr id="16" name="Text 13"/>
           <p:cNvSpPr txBox="1"/>
           <p:nvPr/>
         </p:nvSpPr>
         <p:spPr>
           <a:xfrm>
-            <a:off x="548640" y="5029200"/>
+            <a:off x="2834640" y="5669280"/>
             <a:ext cx="2194560" cy="777240"/>
           </a:xfrm>
           <a:prstGeom prst="rect">
@@ -38446,13 +39260,13 @@
       </p:sp>
       <p:sp>
         <p:nvSpPr>
-          <p:cNvPr id="12" name="Text 9"/>
+          <p:cNvPr id="17" name="Text 14"/>
           <p:cNvSpPr txBox="1"/>
           <p:nvPr/>
         </p:nvSpPr>
         <p:spPr>
           <a:xfrm>
-            <a:off x="548640" y="5779008"/>
+            <a:off x="2834640" y="6419088"/>
             <a:ext cx="2194560" cy="457200"/>
           </a:xfrm>
           <a:prstGeom prst="rect">
@@ -38477,7 +39291,7 @@
                 <a:ea typeface="Arial" pitchFamily="34" charset="-122"/>
                 <a:cs typeface="Arial" pitchFamily="34" charset="-120"/>
               </a:rPr>
-              <a:t>ویدیوی آموزش</a:t>
+              <a:t>کل مجموعه آموزش</a:t>
             </a:r>
             <a:endParaRPr lang="en-US" sz="1200" dirty="0"/>
           </a:p>
@@ -38485,91 +39299,13 @@
       </p:sp>
       <p:sp>
         <p:nvSpPr>
-          <p:cNvPr id="13" name="Text 10"/>
+          <p:cNvPr id="18" name="Text 15"/>
           <p:cNvSpPr txBox="1"/>
           <p:nvPr/>
         </p:nvSpPr>
         <p:spPr>
           <a:xfrm>
-            <a:off x="2834640" y="5029200"/>
-            <a:ext cx="2194560" cy="777240"/>
-          </a:xfrm>
-          <a:prstGeom prst="rect">
-            <a:avLst/>
-          </a:prstGeom>
-          <a:noFill/>
-          <a:ln/>
-        </p:spPr>
-        <p:txBody>
-          <a:bodyPr wrap="square" lIns="0" tIns="0" rIns="0" bIns="0" rtlCol="0" anchor="ctr"/>
-          <a:lstStyle/>
-          <a:p>
-            <a:pPr algn="ctr" indent="0" marL="0">
-              <a:buNone/>
-            </a:pPr>
-            <a:r>
-              <a:rPr lang="en-US" sz="4000" b="1" dirty="0">
-                <a:solidFill>
-                  <a:srgbClr val="16264F"/>
-                </a:solidFill>
-                <a:latin typeface="Arial" pitchFamily="34" charset="0"/>
-                <a:ea typeface="Arial" pitchFamily="34" charset="-122"/>
-                <a:cs typeface="Arial" pitchFamily="34" charset="-120"/>
-              </a:rPr>
-              <a:t>290</a:t>
-            </a:r>
-            <a:endParaRPr lang="en-US" sz="4000" dirty="0"/>
-          </a:p>
-        </p:txBody>
-      </p:sp>
-      <p:sp>
-        <p:nvSpPr>
-          <p:cNvPr id="14" name="Text 11"/>
-          <p:cNvSpPr txBox="1"/>
-          <p:nvPr/>
-        </p:nvSpPr>
-        <p:spPr>
-          <a:xfrm>
-            <a:off x="2834640" y="5779008"/>
-            <a:ext cx="2194560" cy="457200"/>
-          </a:xfrm>
-          <a:prstGeom prst="rect">
-            <a:avLst/>
-          </a:prstGeom>
-          <a:noFill/>
-          <a:ln/>
-        </p:spPr>
-        <p:txBody>
-          <a:bodyPr wrap="square" lIns="0" tIns="0" rIns="0" bIns="0" rtlCol="0" anchor="t"/>
-          <a:lstStyle/>
-          <a:p>
-            <a:pPr rtl="1" algn="ctr" indent="0" marL="0">
-              <a:buNone/>
-            </a:pPr>
-            <a:r>
-              <a:rPr lang="en-US" sz="1200" dirty="0">
-                <a:solidFill>
-                  <a:srgbClr val="6A748C"/>
-                </a:solidFill>
-                <a:latin typeface="Arial" pitchFamily="34" charset="0"/>
-                <a:ea typeface="Arial" pitchFamily="34" charset="-122"/>
-                <a:cs typeface="Arial" pitchFamily="34" charset="-120"/>
-              </a:rPr>
-              <a:t>ویدیوی آزمون</a:t>
-            </a:r>
-            <a:endParaRPr lang="en-US" sz="1200" dirty="0"/>
-          </a:p>
-        </p:txBody>
-      </p:sp>
-      <p:sp>
-        <p:nvSpPr>
-          <p:cNvPr id="15" name="Text 12"/>
-          <p:cNvSpPr txBox="1"/>
-          <p:nvPr/>
-        </p:nvSpPr>
-        <p:spPr>
-          <a:xfrm>
-            <a:off x="5120640" y="5029200"/>
+            <a:off x="5120640" y="5669280"/>
             <a:ext cx="2194560" cy="777240"/>
           </a:xfrm>
           <a:prstGeom prst="rect">
@@ -38602,13 +39338,13 @@
       </p:sp>
       <p:sp>
         <p:nvSpPr>
-          <p:cNvPr id="16" name="Text 13"/>
+          <p:cNvPr id="19" name="Text 16"/>
           <p:cNvSpPr txBox="1"/>
           <p:nvPr/>
         </p:nvSpPr>
         <p:spPr>
           <a:xfrm>
-            <a:off x="5120640" y="5779008"/>
+            <a:off x="5120640" y="6419088"/>
             <a:ext cx="2194560" cy="457200"/>
           </a:xfrm>
           <a:prstGeom prst="rect">
@@ -38636,48 +39372,6 @@
               <a:t>همپوشانی دو مجموعه</a:t>
             </a:r>
             <a:endParaRPr lang="en-US" sz="1200" dirty="0"/>
-          </a:p>
-        </p:txBody>
-      </p:sp>
-      <p:sp>
-        <p:nvSpPr>
-          <p:cNvPr id="17" name="Text 14"/>
-          <p:cNvSpPr txBox="1"/>
-          <p:nvPr/>
-        </p:nvSpPr>
-        <p:spPr>
-          <a:xfrm>
-            <a:off x="548640" y="6080760"/>
-            <a:ext cx="6766560" cy="457200"/>
-          </a:xfrm>
-          <a:prstGeom prst="rect">
-            <a:avLst/>
-          </a:prstGeom>
-          <a:noFill/>
-          <a:ln/>
-        </p:spPr>
-        <p:txBody>
-          <a:bodyPr wrap="square" lIns="0" tIns="0" rIns="0" bIns="0" rtlCol="0" anchor="t"/>
-          <a:lstStyle/>
-          <a:p>
-            <a:pPr rtl="1" algn="r" indent="0" marL="0">
-              <a:lnSpc>
-                <a:spcPts val="1700"/>
-              </a:lnSpc>
-              <a:buNone/>
-            </a:pPr>
-            <a:r>
-              <a:rPr lang="en-US" sz="1150" dirty="0">
-                <a:solidFill>
-                  <a:srgbClr val="6A748C"/>
-                </a:solidFill>
-                <a:latin typeface="Arial" pitchFamily="34" charset="0"/>
-                <a:ea typeface="Arial" pitchFamily="34" charset="-122"/>
-                <a:cs typeface="Arial" pitchFamily="34" charset="-120"/>
-              </a:rPr>
-              <a:t>مجموعه آزمون تا آخرین مرحله دیده نمی‌شود: نه وزن‌ها روی آن آموزش می‌بینند و نه آستانه یا ابرپارامتری روی آن انتخاب می‌شود.</a:t>
-            </a:r>
-            <a:endParaRPr lang="en-US" sz="1150" dirty="0"/>
           </a:p>
         </p:txBody>
       </p:sp>

</xml_diff>

<commit_message>
Drop the parts PowerPoint was refusing
The real blocker was in [Content_Types].xml. pptxgenjs writes one
slideMaster Override per slide while emitting a single master, so the
deck declared 24 parts that do not exist. An Override naming a missing
part makes the package unreadable, which is the "PowerPoint can't read
this file" the earlier repairs never touched.

The progression chart is now drawn with rectangles instead of addChart.
That removes the chart XML, its relationships and the embedded workbook
— the most intricate parts of the package and the ones with the least
margin for a library bug. It reads the same and cannot fail to open.

fix_pptx.py drops dangling overrides alongside the duplicate shape ids,
and its check now audits every part: overrides resolve, every part is
typed, no relationship dangles, all XML parses, no ids collide.

Co-Authored-By: Claude Opus 5 <noreply@anthropic.com>
Claude-Session: https://claude.ai/code/session_01LTN1ToAz7S67GVeppJLK8m
</commit_message>
<xml_diff>
--- a/thesis/Defense_Slides.pptx
+++ b/thesis/Defense_Slides.pptx
@@ -129,331 +129,6 @@
     </a:lvl9pPr>
   </p:defaultTextStyle>
 </p:presentation>
-</file>
-
-<file path=ppt/charts/chart1.xml><?xml version="1.0" encoding="utf-8"?>
-<c:chartSpace xmlns:c="http://schemas.openxmlformats.org/drawingml/2006/chart" xmlns:a="http://schemas.openxmlformats.org/drawingml/2006/main" xmlns:r="http://schemas.openxmlformats.org/officeDocument/2006/relationships">
-  <c:date1904 val="0"/>
-  <c:roundedCorners val="1"/>
-  <c:chart>
-    <c:autoTitleDeleted val="1"/>
-    <c:plotArea>
-      <c:layout/>
-      <c:barChart>
-        <c:barDir val="col"/>
-        <c:grouping val="clustered"/>
-        <c:varyColors val="0"/>
-        <c:ser>
-          <c:idx val="0"/>
-          <c:order val="0"/>
-          <c:tx>
-            <c:strRef>
-              <c:f>Sheet1!$B$1</c:f>
-              <c:strCache>
-                <c:ptCount val="1"/>
-                <c:pt idx="0">
-                  <c:v>macro F1</c:v>
-                </c:pt>
-              </c:strCache>
-            </c:strRef>
-          </c:tx>
-          <c:spPr>
-            <a:solidFill>
-              <a:srgbClr val="16264F"/>
-            </a:solidFill>
-            <a:effectLst/>
-          </c:spPr>
-          <c:invertIfNegative val="0"/>
-          <c:dLbls>
-            <c:numFmt formatCode="0.0000" sourceLinked="0"/>
-            <c:txPr>
-              <a:bodyPr/>
-              <a:lstStyle/>
-              <a:p>
-                <a:pPr>
-                  <a:defRPr b="0" i="0" strike="noStrike" sz="1100" u="none">
-                    <a:solidFill>
-                      <a:srgbClr val="1B2236"/>
-                    </a:solidFill>
-                    <a:latin typeface="Arial"/>
-                  </a:defRPr>
-                </a:pPr>
-              </a:p>
-            </c:txPr>
-            <c:showLegendKey val="0"/>
-            <c:showVal val="1"/>
-            <c:showCatName val="0"/>
-            <c:showSerName val="0"/>
-            <c:showPercent val="0"/>
-            <c:showBubbleSize val="0"/>
-            <c:showLeaderLines val="0"/>
-          </c:dLbls>
-          <c:dPt>
-            <c:idx val="0"/>
-            <c:invertIfNegative val="0"/>
-            <c:bubble3D val="0"/>
-            <c:spPr>
-              <a:solidFill>
-                <a:srgbClr val="16264F"/>
-              </a:solidFill>
-              <a:effectLst/>
-            </c:spPr>
-          </c:dPt>
-          <c:dPt>
-            <c:idx val="1"/>
-            <c:invertIfNegative val="0"/>
-            <c:bubble3D val="0"/>
-            <c:spPr>
-              <a:solidFill>
-                <a:srgbClr val="16264F"/>
-              </a:solidFill>
-              <a:effectLst/>
-            </c:spPr>
-          </c:dPt>
-          <c:dPt>
-            <c:idx val="2"/>
-            <c:invertIfNegative val="0"/>
-            <c:bubble3D val="0"/>
-            <c:spPr>
-              <a:solidFill>
-                <a:srgbClr val="16264F"/>
-              </a:solidFill>
-              <a:effectLst/>
-            </c:spPr>
-          </c:dPt>
-          <c:dPt>
-            <c:idx val="3"/>
-            <c:invertIfNegative val="0"/>
-            <c:bubble3D val="0"/>
-            <c:spPr>
-              <a:solidFill>
-                <a:srgbClr val="E8A33D"/>
-              </a:solidFill>
-              <a:effectLst/>
-            </c:spPr>
-          </c:dPt>
-          <c:dPt>
-            <c:idx val="4"/>
-            <c:invertIfNegative val="0"/>
-            <c:bubble3D val="0"/>
-            <c:spPr>
-              <a:solidFill>
-                <a:srgbClr val="E8A33D"/>
-              </a:solidFill>
-              <a:effectLst/>
-            </c:spPr>
-          </c:dPt>
-          <c:dPt>
-            <c:idx val="5"/>
-            <c:invertIfNegative val="0"/>
-            <c:bubble3D val="0"/>
-            <c:spPr>
-              <a:solidFill>
-                <a:srgbClr val="E8A33D"/>
-              </a:solidFill>
-              <a:effectLst/>
-            </c:spPr>
-          </c:dPt>
-          <c:cat>
-            <c:multiLvlStrRef>
-              <c:f>Sheet1!$A$2:$A$7</c:f>
-              <c:multiLvlStrCache>
-                <c:ptCount val="6"/>
-                <c:lvl>
-                  <c:pt idx="0">
-                    <c:v>MLP / ViT-B</c:v>
-                  </c:pt>
-                  <c:pt idx="1">
-                    <c:v>+ Temporal</c:v>
-                  </c:pt>
-                  <c:pt idx="2">
-                    <c:v>+ lr 3e-4</c:v>
-                  </c:pt>
-                  <c:pt idx="3">
-                    <c:v>+ ViT-L</c:v>
-                  </c:pt>
-                  <c:pt idx="4">
-                    <c:v>+ Mixup</c:v>
-                  </c:pt>
-                  <c:pt idx="5">
-                    <c:v>+ Logit adj.</c:v>
-                  </c:pt>
-                </c:lvl>
-              </c:multiLvlStrCache>
-            </c:multiLvlStrRef>
-          </c:cat>
-          <c:val>
-            <c:numRef>
-              <c:f>Sheet1!$B$2:$B$7</c:f>
-              <c:numCache>
-                <c:formatCode>General</c:formatCode>
-                <c:ptCount val="6"/>
-                <c:pt idx="0">
-                  <c:v>0.2975</c:v>
-                </c:pt>
-                <c:pt idx="1">
-                  <c:v>0.3444</c:v>
-                </c:pt>
-                <c:pt idx="2">
-                  <c:v>0.3645</c:v>
-                </c:pt>
-                <c:pt idx="3">
-                  <c:v>0.4122</c:v>
-                </c:pt>
-                <c:pt idx="4">
-                  <c:v>0.4161</c:v>
-                </c:pt>
-                <c:pt idx="5">
-                  <c:v>0.4298</c:v>
-                </c:pt>
-              </c:numCache>
-            </c:numRef>
-          </c:val>
-        </c:ser>
-        <c:dLbls>
-          <c:numFmt formatCode="0.0000" sourceLinked="0"/>
-          <c:txPr>
-            <a:bodyPr/>
-            <a:lstStyle/>
-            <a:p>
-              <a:pPr>
-                <a:defRPr b="0" i="0" strike="noStrike" sz="1100" u="none">
-                  <a:solidFill>
-                    <a:srgbClr val="1B2236"/>
-                  </a:solidFill>
-                  <a:latin typeface="Arial"/>
-                </a:defRPr>
-              </a:pPr>
-            </a:p>
-          </c:txPr>
-          <c:showLegendKey val="0"/>
-          <c:showVal val="1"/>
-          <c:showCatName val="0"/>
-          <c:showSerName val="0"/>
-          <c:showPercent val="0"/>
-          <c:showBubbleSize val="0"/>
-          <c:showLeaderLines val="0"/>
-        </c:dLbls>
-        <c:gapWidth val="55"/>
-        <c:overlap val="0"/>
-        <c:axId val="2094734554"/>
-        <c:axId val="2094734552"/>
-      </c:barChart>
-      <c:catAx>
-        <c:axId val="2094734554"/>
-        <c:scaling>
-          <c:orientation val="minMax"/>
-        </c:scaling>
-        <c:delete val="0"/>
-        <c:axPos val="b"/>
-        <c:numFmt formatCode="General" sourceLinked="1"/>
-        <c:majorTickMark val="out"/>
-        <c:minorTickMark val="none"/>
-        <c:tickLblPos val="low"/>
-        <c:spPr>
-          <a:ln w="12700" cap="flat">
-            <a:solidFill>
-              <a:srgbClr val="888888"/>
-            </a:solidFill>
-            <a:prstDash val="solid"/>
-            <a:round/>
-          </a:ln>
-        </c:spPr>
-        <c:txPr>
-          <a:bodyPr/>
-          <a:lstStyle/>
-          <a:p>
-            <a:pPr>
-              <a:defRPr sz="1100" b="0" i="0" u="none" strike="noStrike">
-                <a:solidFill>
-                  <a:srgbClr val="1B2236"/>
-                </a:solidFill>
-                <a:latin typeface="Arial"/>
-              </a:defRPr>
-            </a:pPr>
-            <a:endParaRPr lang="en-US"/>
-          </a:p>
-        </c:txPr>
-        <c:crossAx val="2094734552"/>
-        <c:crosses val="autoZero"/>
-        <c:auto val="1"/>
-        <c:lblAlgn val="ctr"/>
-        <c:noMultiLvlLbl val="1"/>
-      </c:catAx>
-      <c:valAx>
-        <c:axId val="2094734552"/>
-        <c:scaling>
-          <c:orientation val="minMax"/>
-          <c:max val="0.46"/>
-          <c:min val="0.25"/>
-        </c:scaling>
-        <c:delete val="0"/>
-        <c:axPos val="l"/>
-        <c:majorGridlines>
-          <c:spPr>
-            <a:ln w="12700" cap="flat">
-              <a:solidFill>
-                <a:srgbClr val="E4E9F2"/>
-              </a:solidFill>
-              <a:prstDash val="solid"/>
-              <a:round/>
-            </a:ln>
-          </c:spPr>
-        </c:majorGridlines>
-        <c:numFmt formatCode="General" sourceLinked="0"/>
-        <c:majorTickMark val="out"/>
-        <c:minorTickMark val="none"/>
-        <c:tickLblPos val="nextTo"/>
-        <c:spPr>
-          <a:ln w="12700" cap="flat">
-            <a:solidFill>
-              <a:srgbClr val="888888"/>
-            </a:solidFill>
-            <a:prstDash val="solid"/>
-            <a:round/>
-          </a:ln>
-        </c:spPr>
-        <c:txPr>
-          <a:bodyPr/>
-          <a:lstStyle/>
-          <a:p>
-            <a:pPr>
-              <a:defRPr sz="1000" b="0" i="0" u="none" strike="noStrike">
-                <a:solidFill>
-                  <a:srgbClr val="6A748C"/>
-                </a:solidFill>
-                <a:latin typeface="Arial"/>
-              </a:defRPr>
-            </a:pPr>
-            <a:endParaRPr lang="en-US"/>
-          </a:p>
-        </c:txPr>
-        <c:crossAx val="2094734554"/>
-        <c:crosses val="autoZero"/>
-        <c:crossBetween val="between"/>
-      </c:valAx>
-      <c:spPr>
-        <a:noFill/>
-        <a:ln>
-          <a:noFill/>
-        </a:ln>
-        <a:effectLst/>
-      </c:spPr>
-    </c:plotArea>
-    <c:plotVisOnly val="1"/>
-    <c:dispBlanksAs val="span"/>
-  </c:chart>
-  <c:spPr>
-    <a:noFill/>
-    <a:ln>
-      <a:noFill/>
-    </a:ln>
-    <a:effectLst/>
-  </c:spPr>
-  <c:externalData r:id="rId1">
-    <c:autoUpdate val="0"/>
-  </c:externalData>
-</c:chartSpace>
 </file>
 
 <file path=ppt/notesMasters/notesMaster1.xml><?xml version="1.0" encoding="utf-8"?>
@@ -22133,25 +21808,908 @@
           </a:p>
         </p:txBody>
       </p:sp>
-      <p:graphicFrame>
-        <p:nvGraphicFramePr>
-          <p:cNvPr id="4" name="Chart 0" descr=""/>
-          <p:cNvGraphicFramePr/>
-          <p:nvPr/>
-        </p:nvGraphicFramePr>
-        <p:xfrm>
-          <a:off x="548640" y="1645920"/>
-          <a:ext cx="11064240" cy="3291840"/>
-        </p:xfrm>
-        <a:graphic xmlns:a="http://schemas.openxmlformats.org/drawingml/2006/main">
-          <a:graphicData uri="http://schemas.openxmlformats.org/drawingml/2006/chart">
-            <c:chart xmlns:c="http://schemas.openxmlformats.org/drawingml/2006/chart" r:id="rId1"/>
-          </a:graphicData>
-        </a:graphic>
-      </p:graphicFrame>
       <p:sp>
         <p:nvSpPr>
-          <p:cNvPr id="5" name="Text 2"/>
+          <p:cNvPr id="4" name="Shape 2"/>
+          <p:cNvSpPr/>
+          <p:nvPr/>
+        </p:nvSpPr>
+        <p:spPr>
+          <a:xfrm>
+            <a:off x="1325880" y="4116977"/>
+            <a:ext cx="10287000" cy="18288"/>
+          </a:xfrm>
+          <a:prstGeom prst="rect">
+            <a:avLst/>
+          </a:prstGeom>
+          <a:solidFill>
+            <a:srgbClr val="E4E9F2"/>
+          </a:solidFill>
+          <a:ln w="12700">
+            <a:solidFill>
+              <a:srgbClr val="E4E9F2"/>
+            </a:solidFill>
+            <a:prstDash val="solid"/>
+          </a:ln>
+        </p:spPr>
+      </p:sp>
+      <p:sp>
+        <p:nvSpPr>
+          <p:cNvPr id="5" name="Text 3"/>
+          <p:cNvSpPr txBox="1"/>
+          <p:nvPr/>
+        </p:nvSpPr>
+        <p:spPr>
+          <a:xfrm>
+            <a:off x="548640" y="3988961"/>
+            <a:ext cx="685800" cy="256032"/>
+          </a:xfrm>
+          <a:prstGeom prst="rect">
+            <a:avLst/>
+          </a:prstGeom>
+          <a:noFill/>
+          <a:ln/>
+        </p:spPr>
+        <p:txBody>
+          <a:bodyPr wrap="square" lIns="0" tIns="0" rIns="0" bIns="0" rtlCol="0" anchor="t"/>
+          <a:lstStyle/>
+          <a:p>
+            <a:pPr algn="r" indent="0" marL="0">
+              <a:buNone/>
+            </a:pPr>
+            <a:r>
+              <a:rPr lang="en-US" sz="1000" dirty="0">
+                <a:solidFill>
+                  <a:srgbClr val="6A748C"/>
+                </a:solidFill>
+                <a:latin typeface="Arial" pitchFamily="34" charset="0"/>
+                <a:ea typeface="Arial" pitchFamily="34" charset="-122"/>
+                <a:cs typeface="Arial" pitchFamily="34" charset="-120"/>
+              </a:rPr>
+              <a:t>0.30</a:t>
+            </a:r>
+            <a:endParaRPr lang="en-US" sz="1000" dirty="0"/>
+          </a:p>
+        </p:txBody>
+      </p:sp>
+      <p:sp>
+        <p:nvSpPr>
+          <p:cNvPr id="6" name="Shape 4"/>
+          <p:cNvSpPr/>
+          <p:nvPr/>
+        </p:nvSpPr>
+        <p:spPr>
+          <a:xfrm>
+            <a:off x="1325880" y="3387634"/>
+            <a:ext cx="10287000" cy="18288"/>
+          </a:xfrm>
+          <a:prstGeom prst="rect">
+            <a:avLst/>
+          </a:prstGeom>
+          <a:solidFill>
+            <a:srgbClr val="E4E9F2"/>
+          </a:solidFill>
+          <a:ln w="12700">
+            <a:solidFill>
+              <a:srgbClr val="E4E9F2"/>
+            </a:solidFill>
+            <a:prstDash val="solid"/>
+          </a:ln>
+        </p:spPr>
+      </p:sp>
+      <p:sp>
+        <p:nvSpPr>
+          <p:cNvPr id="7" name="Text 5"/>
+          <p:cNvSpPr txBox="1"/>
+          <p:nvPr/>
+        </p:nvSpPr>
+        <p:spPr>
+          <a:xfrm>
+            <a:off x="548640" y="3259618"/>
+            <a:ext cx="685800" cy="256032"/>
+          </a:xfrm>
+          <a:prstGeom prst="rect">
+            <a:avLst/>
+          </a:prstGeom>
+          <a:noFill/>
+          <a:ln/>
+        </p:spPr>
+        <p:txBody>
+          <a:bodyPr wrap="square" lIns="0" tIns="0" rIns="0" bIns="0" rtlCol="0" anchor="t"/>
+          <a:lstStyle/>
+          <a:p>
+            <a:pPr algn="r" indent="0" marL="0">
+              <a:buNone/>
+            </a:pPr>
+            <a:r>
+              <a:rPr lang="en-US" sz="1000" dirty="0">
+                <a:solidFill>
+                  <a:srgbClr val="6A748C"/>
+                </a:solidFill>
+                <a:latin typeface="Arial" pitchFamily="34" charset="0"/>
+                <a:ea typeface="Arial" pitchFamily="34" charset="-122"/>
+                <a:cs typeface="Arial" pitchFamily="34" charset="-120"/>
+              </a:rPr>
+              <a:t>0.35</a:t>
+            </a:r>
+            <a:endParaRPr lang="en-US" sz="1000" dirty="0"/>
+          </a:p>
+        </p:txBody>
+      </p:sp>
+      <p:sp>
+        <p:nvSpPr>
+          <p:cNvPr id="8" name="Shape 6"/>
+          <p:cNvSpPr/>
+          <p:nvPr/>
+        </p:nvSpPr>
+        <p:spPr>
+          <a:xfrm>
+            <a:off x="1325880" y="2658291"/>
+            <a:ext cx="10287000" cy="18288"/>
+          </a:xfrm>
+          <a:prstGeom prst="rect">
+            <a:avLst/>
+          </a:prstGeom>
+          <a:solidFill>
+            <a:srgbClr val="E4E9F2"/>
+          </a:solidFill>
+          <a:ln w="12700">
+            <a:solidFill>
+              <a:srgbClr val="E4E9F2"/>
+            </a:solidFill>
+            <a:prstDash val="solid"/>
+          </a:ln>
+        </p:spPr>
+      </p:sp>
+      <p:sp>
+        <p:nvSpPr>
+          <p:cNvPr id="9" name="Text 7"/>
+          <p:cNvSpPr txBox="1"/>
+          <p:nvPr/>
+        </p:nvSpPr>
+        <p:spPr>
+          <a:xfrm>
+            <a:off x="548640" y="2530275"/>
+            <a:ext cx="685800" cy="256032"/>
+          </a:xfrm>
+          <a:prstGeom prst="rect">
+            <a:avLst/>
+          </a:prstGeom>
+          <a:noFill/>
+          <a:ln/>
+        </p:spPr>
+        <p:txBody>
+          <a:bodyPr wrap="square" lIns="0" tIns="0" rIns="0" bIns="0" rtlCol="0" anchor="t"/>
+          <a:lstStyle/>
+          <a:p>
+            <a:pPr algn="r" indent="0" marL="0">
+              <a:buNone/>
+            </a:pPr>
+            <a:r>
+              <a:rPr lang="en-US" sz="1000" dirty="0">
+                <a:solidFill>
+                  <a:srgbClr val="6A748C"/>
+                </a:solidFill>
+                <a:latin typeface="Arial" pitchFamily="34" charset="0"/>
+                <a:ea typeface="Arial" pitchFamily="34" charset="-122"/>
+                <a:cs typeface="Arial" pitchFamily="34" charset="-120"/>
+              </a:rPr>
+              <a:t>0.40</a:t>
+            </a:r>
+            <a:endParaRPr lang="en-US" sz="1000" dirty="0"/>
+          </a:p>
+        </p:txBody>
+      </p:sp>
+      <p:sp>
+        <p:nvSpPr>
+          <p:cNvPr id="10" name="Shape 8"/>
+          <p:cNvSpPr/>
+          <p:nvPr/>
+        </p:nvSpPr>
+        <p:spPr>
+          <a:xfrm>
+            <a:off x="1325880" y="1928949"/>
+            <a:ext cx="10287000" cy="18288"/>
+          </a:xfrm>
+          <a:prstGeom prst="rect">
+            <a:avLst/>
+          </a:prstGeom>
+          <a:solidFill>
+            <a:srgbClr val="E4E9F2"/>
+          </a:solidFill>
+          <a:ln w="12700">
+            <a:solidFill>
+              <a:srgbClr val="E4E9F2"/>
+            </a:solidFill>
+            <a:prstDash val="solid"/>
+          </a:ln>
+        </p:spPr>
+      </p:sp>
+      <p:sp>
+        <p:nvSpPr>
+          <p:cNvPr id="11" name="Text 9"/>
+          <p:cNvSpPr txBox="1"/>
+          <p:nvPr/>
+        </p:nvSpPr>
+        <p:spPr>
+          <a:xfrm>
+            <a:off x="548640" y="1800933"/>
+            <a:ext cx="685800" cy="256032"/>
+          </a:xfrm>
+          <a:prstGeom prst="rect">
+            <a:avLst/>
+          </a:prstGeom>
+          <a:noFill/>
+          <a:ln/>
+        </p:spPr>
+        <p:txBody>
+          <a:bodyPr wrap="square" lIns="0" tIns="0" rIns="0" bIns="0" rtlCol="0" anchor="t"/>
+          <a:lstStyle/>
+          <a:p>
+            <a:pPr algn="r" indent="0" marL="0">
+              <a:buNone/>
+            </a:pPr>
+            <a:r>
+              <a:rPr lang="en-US" sz="1000" dirty="0">
+                <a:solidFill>
+                  <a:srgbClr val="6A748C"/>
+                </a:solidFill>
+                <a:latin typeface="Arial" pitchFamily="34" charset="0"/>
+                <a:ea typeface="Arial" pitchFamily="34" charset="-122"/>
+                <a:cs typeface="Arial" pitchFamily="34" charset="-120"/>
+              </a:rPr>
+              <a:t>0.45</a:t>
+            </a:r>
+            <a:endParaRPr lang="en-US" sz="1000" dirty="0"/>
+          </a:p>
+        </p:txBody>
+      </p:sp>
+      <p:sp>
+        <p:nvSpPr>
+          <p:cNvPr id="12" name="Shape 10"/>
+          <p:cNvSpPr/>
+          <p:nvPr/>
+        </p:nvSpPr>
+        <p:spPr>
+          <a:xfrm>
+            <a:off x="1325880" y="4846320"/>
+            <a:ext cx="10287000" cy="22860"/>
+          </a:xfrm>
+          <a:prstGeom prst="rect">
+            <a:avLst/>
+          </a:prstGeom>
+          <a:solidFill>
+            <a:srgbClr val="C7D0E0"/>
+          </a:solidFill>
+          <a:ln w="12700">
+            <a:solidFill>
+              <a:srgbClr val="C7D0E0"/>
+            </a:solidFill>
+            <a:prstDash val="solid"/>
+          </a:ln>
+        </p:spPr>
+      </p:sp>
+      <p:sp>
+        <p:nvSpPr>
+          <p:cNvPr id="13" name="Shape 11"/>
+          <p:cNvSpPr/>
+          <p:nvPr/>
+        </p:nvSpPr>
+        <p:spPr>
+          <a:xfrm>
+            <a:off x="1588770" y="4153444"/>
+            <a:ext cx="1188720" cy="692876"/>
+          </a:xfrm>
+          <a:prstGeom prst="rect">
+            <a:avLst/>
+          </a:prstGeom>
+          <a:solidFill>
+            <a:srgbClr val="16264F"/>
+          </a:solidFill>
+          <a:ln w="12700">
+            <a:solidFill>
+              <a:srgbClr val="333333"/>
+            </a:solidFill>
+            <a:prstDash val="solid"/>
+          </a:ln>
+        </p:spPr>
+      </p:sp>
+      <p:sp>
+        <p:nvSpPr>
+          <p:cNvPr id="14" name="Text 12"/>
+          <p:cNvSpPr txBox="1"/>
+          <p:nvPr/>
+        </p:nvSpPr>
+        <p:spPr>
+          <a:xfrm>
+            <a:off x="1360170" y="3842548"/>
+            <a:ext cx="1645920" cy="274320"/>
+          </a:xfrm>
+          <a:prstGeom prst="rect">
+            <a:avLst/>
+          </a:prstGeom>
+          <a:noFill/>
+          <a:ln/>
+        </p:spPr>
+        <p:txBody>
+          <a:bodyPr wrap="square" lIns="0" tIns="0" rIns="0" bIns="0" rtlCol="0" anchor="t"/>
+          <a:lstStyle/>
+          <a:p>
+            <a:pPr algn="ctr" indent="0" marL="0">
+              <a:buNone/>
+            </a:pPr>
+            <a:r>
+              <a:rPr lang="en-US" sz="1100" b="1" dirty="0">
+                <a:solidFill>
+                  <a:srgbClr val="1B2236"/>
+                </a:solidFill>
+                <a:latin typeface="Arial" pitchFamily="34" charset="0"/>
+                <a:ea typeface="Arial" pitchFamily="34" charset="-122"/>
+                <a:cs typeface="Arial" pitchFamily="34" charset="-120"/>
+              </a:rPr>
+              <a:t>0.2975</a:t>
+            </a:r>
+            <a:endParaRPr lang="en-US" sz="1100" dirty="0"/>
+          </a:p>
+        </p:txBody>
+      </p:sp>
+      <p:sp>
+        <p:nvSpPr>
+          <p:cNvPr id="15" name="Text 13"/>
+          <p:cNvSpPr txBox="1"/>
+          <p:nvPr/>
+        </p:nvSpPr>
+        <p:spPr>
+          <a:xfrm>
+            <a:off x="1268730" y="4937760"/>
+            <a:ext cx="1828800" cy="274320"/>
+          </a:xfrm>
+          <a:prstGeom prst="rect">
+            <a:avLst/>
+          </a:prstGeom>
+          <a:noFill/>
+          <a:ln/>
+        </p:spPr>
+        <p:txBody>
+          <a:bodyPr wrap="square" lIns="0" tIns="0" rIns="0" bIns="0" rtlCol="0" anchor="t"/>
+          <a:lstStyle/>
+          <a:p>
+            <a:pPr algn="ctr" indent="0" marL="0">
+              <a:buNone/>
+            </a:pPr>
+            <a:r>
+              <a:rPr lang="en-US" sz="1100" dirty="0">
+                <a:solidFill>
+                  <a:srgbClr val="1B2236"/>
+                </a:solidFill>
+                <a:latin typeface="Arial" pitchFamily="34" charset="0"/>
+                <a:ea typeface="Arial" pitchFamily="34" charset="-122"/>
+                <a:cs typeface="Arial" pitchFamily="34" charset="-120"/>
+              </a:rPr>
+              <a:t>MLP / ViT-B</a:t>
+            </a:r>
+            <a:endParaRPr lang="en-US" sz="1100" dirty="0"/>
+          </a:p>
+        </p:txBody>
+      </p:sp>
+      <p:sp>
+        <p:nvSpPr>
+          <p:cNvPr id="16" name="Shape 14"/>
+          <p:cNvSpPr/>
+          <p:nvPr/>
+        </p:nvSpPr>
+        <p:spPr>
+          <a:xfrm>
+            <a:off x="3303270" y="3469321"/>
+            <a:ext cx="1188720" cy="1376999"/>
+          </a:xfrm>
+          <a:prstGeom prst="rect">
+            <a:avLst/>
+          </a:prstGeom>
+          <a:solidFill>
+            <a:srgbClr val="16264F"/>
+          </a:solidFill>
+          <a:ln w="12700">
+            <a:solidFill>
+              <a:srgbClr val="333333"/>
+            </a:solidFill>
+            <a:prstDash val="solid"/>
+          </a:ln>
+        </p:spPr>
+      </p:sp>
+      <p:sp>
+        <p:nvSpPr>
+          <p:cNvPr id="17" name="Text 15"/>
+          <p:cNvSpPr txBox="1"/>
+          <p:nvPr/>
+        </p:nvSpPr>
+        <p:spPr>
+          <a:xfrm>
+            <a:off x="3074670" y="3158425"/>
+            <a:ext cx="1645920" cy="274320"/>
+          </a:xfrm>
+          <a:prstGeom prst="rect">
+            <a:avLst/>
+          </a:prstGeom>
+          <a:noFill/>
+          <a:ln/>
+        </p:spPr>
+        <p:txBody>
+          <a:bodyPr wrap="square" lIns="0" tIns="0" rIns="0" bIns="0" rtlCol="0" anchor="t"/>
+          <a:lstStyle/>
+          <a:p>
+            <a:pPr algn="ctr" indent="0" marL="0">
+              <a:buNone/>
+            </a:pPr>
+            <a:r>
+              <a:rPr lang="en-US" sz="1100" b="1" dirty="0">
+                <a:solidFill>
+                  <a:srgbClr val="1B2236"/>
+                </a:solidFill>
+                <a:latin typeface="Arial" pitchFamily="34" charset="0"/>
+                <a:ea typeface="Arial" pitchFamily="34" charset="-122"/>
+                <a:cs typeface="Arial" pitchFamily="34" charset="-120"/>
+              </a:rPr>
+              <a:t>0.3444</a:t>
+            </a:r>
+            <a:endParaRPr lang="en-US" sz="1100" dirty="0"/>
+          </a:p>
+        </p:txBody>
+      </p:sp>
+      <p:sp>
+        <p:nvSpPr>
+          <p:cNvPr id="18" name="Text 16"/>
+          <p:cNvSpPr txBox="1"/>
+          <p:nvPr/>
+        </p:nvSpPr>
+        <p:spPr>
+          <a:xfrm>
+            <a:off x="2983230" y="4937760"/>
+            <a:ext cx="1828800" cy="274320"/>
+          </a:xfrm>
+          <a:prstGeom prst="rect">
+            <a:avLst/>
+          </a:prstGeom>
+          <a:noFill/>
+          <a:ln/>
+        </p:spPr>
+        <p:txBody>
+          <a:bodyPr wrap="square" lIns="0" tIns="0" rIns="0" bIns="0" rtlCol="0" anchor="t"/>
+          <a:lstStyle/>
+          <a:p>
+            <a:pPr algn="ctr" indent="0" marL="0">
+              <a:buNone/>
+            </a:pPr>
+            <a:r>
+              <a:rPr lang="en-US" sz="1100" dirty="0">
+                <a:solidFill>
+                  <a:srgbClr val="1B2236"/>
+                </a:solidFill>
+                <a:latin typeface="Arial" pitchFamily="34" charset="0"/>
+                <a:ea typeface="Arial" pitchFamily="34" charset="-122"/>
+                <a:cs typeface="Arial" pitchFamily="34" charset="-120"/>
+              </a:rPr>
+              <a:t>+ Temporal</a:t>
+            </a:r>
+            <a:endParaRPr lang="en-US" sz="1100" dirty="0"/>
+          </a:p>
+        </p:txBody>
+      </p:sp>
+      <p:sp>
+        <p:nvSpPr>
+          <p:cNvPr id="19" name="Shape 17"/>
+          <p:cNvSpPr/>
+          <p:nvPr/>
+        </p:nvSpPr>
+        <p:spPr>
+          <a:xfrm>
+            <a:off x="5017770" y="3176125"/>
+            <a:ext cx="1188720" cy="1670195"/>
+          </a:xfrm>
+          <a:prstGeom prst="rect">
+            <a:avLst/>
+          </a:prstGeom>
+          <a:solidFill>
+            <a:srgbClr val="16264F"/>
+          </a:solidFill>
+          <a:ln w="12700">
+            <a:solidFill>
+              <a:srgbClr val="333333"/>
+            </a:solidFill>
+            <a:prstDash val="solid"/>
+          </a:ln>
+        </p:spPr>
+      </p:sp>
+      <p:sp>
+        <p:nvSpPr>
+          <p:cNvPr id="20" name="Text 18"/>
+          <p:cNvSpPr txBox="1"/>
+          <p:nvPr/>
+        </p:nvSpPr>
+        <p:spPr>
+          <a:xfrm>
+            <a:off x="4789170" y="2865229"/>
+            <a:ext cx="1645920" cy="274320"/>
+          </a:xfrm>
+          <a:prstGeom prst="rect">
+            <a:avLst/>
+          </a:prstGeom>
+          <a:noFill/>
+          <a:ln/>
+        </p:spPr>
+        <p:txBody>
+          <a:bodyPr wrap="square" lIns="0" tIns="0" rIns="0" bIns="0" rtlCol="0" anchor="t"/>
+          <a:lstStyle/>
+          <a:p>
+            <a:pPr algn="ctr" indent="0" marL="0">
+              <a:buNone/>
+            </a:pPr>
+            <a:r>
+              <a:rPr lang="en-US" sz="1100" b="1" dirty="0">
+                <a:solidFill>
+                  <a:srgbClr val="1B2236"/>
+                </a:solidFill>
+                <a:latin typeface="Arial" pitchFamily="34" charset="0"/>
+                <a:ea typeface="Arial" pitchFamily="34" charset="-122"/>
+                <a:cs typeface="Arial" pitchFamily="34" charset="-120"/>
+              </a:rPr>
+              <a:t>0.3645</a:t>
+            </a:r>
+            <a:endParaRPr lang="en-US" sz="1100" dirty="0"/>
+          </a:p>
+        </p:txBody>
+      </p:sp>
+      <p:sp>
+        <p:nvSpPr>
+          <p:cNvPr id="21" name="Text 19"/>
+          <p:cNvSpPr txBox="1"/>
+          <p:nvPr/>
+        </p:nvSpPr>
+        <p:spPr>
+          <a:xfrm>
+            <a:off x="4697730" y="4937760"/>
+            <a:ext cx="1828800" cy="274320"/>
+          </a:xfrm>
+          <a:prstGeom prst="rect">
+            <a:avLst/>
+          </a:prstGeom>
+          <a:noFill/>
+          <a:ln/>
+        </p:spPr>
+        <p:txBody>
+          <a:bodyPr wrap="square" lIns="0" tIns="0" rIns="0" bIns="0" rtlCol="0" anchor="t"/>
+          <a:lstStyle/>
+          <a:p>
+            <a:pPr algn="ctr" indent="0" marL="0">
+              <a:buNone/>
+            </a:pPr>
+            <a:r>
+              <a:rPr lang="en-US" sz="1100" dirty="0">
+                <a:solidFill>
+                  <a:srgbClr val="1B2236"/>
+                </a:solidFill>
+                <a:latin typeface="Arial" pitchFamily="34" charset="0"/>
+                <a:ea typeface="Arial" pitchFamily="34" charset="-122"/>
+                <a:cs typeface="Arial" pitchFamily="34" charset="-120"/>
+              </a:rPr>
+              <a:t>+ lr 3e-4</a:t>
+            </a:r>
+            <a:endParaRPr lang="en-US" sz="1100" dirty="0"/>
+          </a:p>
+        </p:txBody>
+      </p:sp>
+      <p:sp>
+        <p:nvSpPr>
+          <p:cNvPr id="22" name="Shape 20"/>
+          <p:cNvSpPr/>
+          <p:nvPr/>
+        </p:nvSpPr>
+        <p:spPr>
+          <a:xfrm>
+            <a:off x="6732270" y="2480332"/>
+            <a:ext cx="1188720" cy="2365988"/>
+          </a:xfrm>
+          <a:prstGeom prst="rect">
+            <a:avLst/>
+          </a:prstGeom>
+          <a:solidFill>
+            <a:srgbClr val="E8A33D"/>
+          </a:solidFill>
+          <a:ln w="12700">
+            <a:solidFill>
+              <a:srgbClr val="333333"/>
+            </a:solidFill>
+            <a:prstDash val="solid"/>
+          </a:ln>
+        </p:spPr>
+      </p:sp>
+      <p:sp>
+        <p:nvSpPr>
+          <p:cNvPr id="23" name="Text 21"/>
+          <p:cNvSpPr txBox="1"/>
+          <p:nvPr/>
+        </p:nvSpPr>
+        <p:spPr>
+          <a:xfrm>
+            <a:off x="6503670" y="2169436"/>
+            <a:ext cx="1645920" cy="274320"/>
+          </a:xfrm>
+          <a:prstGeom prst="rect">
+            <a:avLst/>
+          </a:prstGeom>
+          <a:noFill/>
+          <a:ln/>
+        </p:spPr>
+        <p:txBody>
+          <a:bodyPr wrap="square" lIns="0" tIns="0" rIns="0" bIns="0" rtlCol="0" anchor="t"/>
+          <a:lstStyle/>
+          <a:p>
+            <a:pPr algn="ctr" indent="0" marL="0">
+              <a:buNone/>
+            </a:pPr>
+            <a:r>
+              <a:rPr lang="en-US" sz="1100" b="1" dirty="0">
+                <a:solidFill>
+                  <a:srgbClr val="1B2236"/>
+                </a:solidFill>
+                <a:latin typeface="Arial" pitchFamily="34" charset="0"/>
+                <a:ea typeface="Arial" pitchFamily="34" charset="-122"/>
+                <a:cs typeface="Arial" pitchFamily="34" charset="-120"/>
+              </a:rPr>
+              <a:t>0.4122</a:t>
+            </a:r>
+            <a:endParaRPr lang="en-US" sz="1100" dirty="0"/>
+          </a:p>
+        </p:txBody>
+      </p:sp>
+      <p:sp>
+        <p:nvSpPr>
+          <p:cNvPr id="24" name="Text 22"/>
+          <p:cNvSpPr txBox="1"/>
+          <p:nvPr/>
+        </p:nvSpPr>
+        <p:spPr>
+          <a:xfrm>
+            <a:off x="6412230" y="4937760"/>
+            <a:ext cx="1828800" cy="274320"/>
+          </a:xfrm>
+          <a:prstGeom prst="rect">
+            <a:avLst/>
+          </a:prstGeom>
+          <a:noFill/>
+          <a:ln/>
+        </p:spPr>
+        <p:txBody>
+          <a:bodyPr wrap="square" lIns="0" tIns="0" rIns="0" bIns="0" rtlCol="0" anchor="t"/>
+          <a:lstStyle/>
+          <a:p>
+            <a:pPr algn="ctr" indent="0" marL="0">
+              <a:buNone/>
+            </a:pPr>
+            <a:r>
+              <a:rPr lang="en-US" sz="1100" dirty="0">
+                <a:solidFill>
+                  <a:srgbClr val="1B2236"/>
+                </a:solidFill>
+                <a:latin typeface="Arial" pitchFamily="34" charset="0"/>
+                <a:ea typeface="Arial" pitchFamily="34" charset="-122"/>
+                <a:cs typeface="Arial" pitchFamily="34" charset="-120"/>
+              </a:rPr>
+              <a:t>+ ViT-L</a:t>
+            </a:r>
+            <a:endParaRPr lang="en-US" sz="1100" dirty="0"/>
+          </a:p>
+        </p:txBody>
+      </p:sp>
+      <p:sp>
+        <p:nvSpPr>
+          <p:cNvPr id="25" name="Shape 23"/>
+          <p:cNvSpPr/>
+          <p:nvPr/>
+        </p:nvSpPr>
+        <p:spPr>
+          <a:xfrm>
+            <a:off x="8446770" y="2423443"/>
+            <a:ext cx="1188720" cy="2422877"/>
+          </a:xfrm>
+          <a:prstGeom prst="rect">
+            <a:avLst/>
+          </a:prstGeom>
+          <a:solidFill>
+            <a:srgbClr val="E8A33D"/>
+          </a:solidFill>
+          <a:ln w="12700">
+            <a:solidFill>
+              <a:srgbClr val="333333"/>
+            </a:solidFill>
+            <a:prstDash val="solid"/>
+          </a:ln>
+        </p:spPr>
+      </p:sp>
+      <p:sp>
+        <p:nvSpPr>
+          <p:cNvPr id="26" name="Text 24"/>
+          <p:cNvSpPr txBox="1"/>
+          <p:nvPr/>
+        </p:nvSpPr>
+        <p:spPr>
+          <a:xfrm>
+            <a:off x="8218170" y="2112547"/>
+            <a:ext cx="1645920" cy="274320"/>
+          </a:xfrm>
+          <a:prstGeom prst="rect">
+            <a:avLst/>
+          </a:prstGeom>
+          <a:noFill/>
+          <a:ln/>
+        </p:spPr>
+        <p:txBody>
+          <a:bodyPr wrap="square" lIns="0" tIns="0" rIns="0" bIns="0" rtlCol="0" anchor="t"/>
+          <a:lstStyle/>
+          <a:p>
+            <a:pPr algn="ctr" indent="0" marL="0">
+              <a:buNone/>
+            </a:pPr>
+            <a:r>
+              <a:rPr lang="en-US" sz="1100" b="1" dirty="0">
+                <a:solidFill>
+                  <a:srgbClr val="1B2236"/>
+                </a:solidFill>
+                <a:latin typeface="Arial" pitchFamily="34" charset="0"/>
+                <a:ea typeface="Arial" pitchFamily="34" charset="-122"/>
+                <a:cs typeface="Arial" pitchFamily="34" charset="-120"/>
+              </a:rPr>
+              <a:t>0.4161</a:t>
+            </a:r>
+            <a:endParaRPr lang="en-US" sz="1100" dirty="0"/>
+          </a:p>
+        </p:txBody>
+      </p:sp>
+      <p:sp>
+        <p:nvSpPr>
+          <p:cNvPr id="27" name="Text 25"/>
+          <p:cNvSpPr txBox="1"/>
+          <p:nvPr/>
+        </p:nvSpPr>
+        <p:spPr>
+          <a:xfrm>
+            <a:off x="8126730" y="4937760"/>
+            <a:ext cx="1828800" cy="274320"/>
+          </a:xfrm>
+          <a:prstGeom prst="rect">
+            <a:avLst/>
+          </a:prstGeom>
+          <a:noFill/>
+          <a:ln/>
+        </p:spPr>
+        <p:txBody>
+          <a:bodyPr wrap="square" lIns="0" tIns="0" rIns="0" bIns="0" rtlCol="0" anchor="t"/>
+          <a:lstStyle/>
+          <a:p>
+            <a:pPr algn="ctr" indent="0" marL="0">
+              <a:buNone/>
+            </a:pPr>
+            <a:r>
+              <a:rPr lang="en-US" sz="1100" dirty="0">
+                <a:solidFill>
+                  <a:srgbClr val="1B2236"/>
+                </a:solidFill>
+                <a:latin typeface="Arial" pitchFamily="34" charset="0"/>
+                <a:ea typeface="Arial" pitchFamily="34" charset="-122"/>
+                <a:cs typeface="Arial" pitchFamily="34" charset="-120"/>
+              </a:rPr>
+              <a:t>+ Mixup</a:t>
+            </a:r>
+            <a:endParaRPr lang="en-US" sz="1100" dirty="0"/>
+          </a:p>
+        </p:txBody>
+      </p:sp>
+      <p:sp>
+        <p:nvSpPr>
+          <p:cNvPr id="28" name="Shape 26"/>
+          <p:cNvSpPr/>
+          <p:nvPr/>
+        </p:nvSpPr>
+        <p:spPr>
+          <a:xfrm>
+            <a:off x="10161270" y="2223603"/>
+            <a:ext cx="1188720" cy="2622717"/>
+          </a:xfrm>
+          <a:prstGeom prst="rect">
+            <a:avLst/>
+          </a:prstGeom>
+          <a:solidFill>
+            <a:srgbClr val="E8A33D"/>
+          </a:solidFill>
+          <a:ln w="12700">
+            <a:solidFill>
+              <a:srgbClr val="333333"/>
+            </a:solidFill>
+            <a:prstDash val="solid"/>
+          </a:ln>
+        </p:spPr>
+      </p:sp>
+      <p:sp>
+        <p:nvSpPr>
+          <p:cNvPr id="29" name="Text 27"/>
+          <p:cNvSpPr txBox="1"/>
+          <p:nvPr/>
+        </p:nvSpPr>
+        <p:spPr>
+          <a:xfrm>
+            <a:off x="9932670" y="1912707"/>
+            <a:ext cx="1645920" cy="274320"/>
+          </a:xfrm>
+          <a:prstGeom prst="rect">
+            <a:avLst/>
+          </a:prstGeom>
+          <a:noFill/>
+          <a:ln/>
+        </p:spPr>
+        <p:txBody>
+          <a:bodyPr wrap="square" lIns="0" tIns="0" rIns="0" bIns="0" rtlCol="0" anchor="t"/>
+          <a:lstStyle/>
+          <a:p>
+            <a:pPr algn="ctr" indent="0" marL="0">
+              <a:buNone/>
+            </a:pPr>
+            <a:r>
+              <a:rPr lang="en-US" sz="1100" b="1" dirty="0">
+                <a:solidFill>
+                  <a:srgbClr val="1B2236"/>
+                </a:solidFill>
+                <a:latin typeface="Arial" pitchFamily="34" charset="0"/>
+                <a:ea typeface="Arial" pitchFamily="34" charset="-122"/>
+                <a:cs typeface="Arial" pitchFamily="34" charset="-120"/>
+              </a:rPr>
+              <a:t>0.4298</a:t>
+            </a:r>
+            <a:endParaRPr lang="en-US" sz="1100" dirty="0"/>
+          </a:p>
+        </p:txBody>
+      </p:sp>
+      <p:sp>
+        <p:nvSpPr>
+          <p:cNvPr id="30" name="Text 28"/>
+          <p:cNvSpPr txBox="1"/>
+          <p:nvPr/>
+        </p:nvSpPr>
+        <p:spPr>
+          <a:xfrm>
+            <a:off x="9841230" y="4937760"/>
+            <a:ext cx="1828800" cy="274320"/>
+          </a:xfrm>
+          <a:prstGeom prst="rect">
+            <a:avLst/>
+          </a:prstGeom>
+          <a:noFill/>
+          <a:ln/>
+        </p:spPr>
+        <p:txBody>
+          <a:bodyPr wrap="square" lIns="0" tIns="0" rIns="0" bIns="0" rtlCol="0" anchor="t"/>
+          <a:lstStyle/>
+          <a:p>
+            <a:pPr algn="ctr" indent="0" marL="0">
+              <a:buNone/>
+            </a:pPr>
+            <a:r>
+              <a:rPr lang="en-US" sz="1100" dirty="0">
+                <a:solidFill>
+                  <a:srgbClr val="1B2236"/>
+                </a:solidFill>
+                <a:latin typeface="Arial" pitchFamily="34" charset="0"/>
+                <a:ea typeface="Arial" pitchFamily="34" charset="-122"/>
+                <a:cs typeface="Arial" pitchFamily="34" charset="-120"/>
+              </a:rPr>
+              <a:t>+ Logit adj.</a:t>
+            </a:r>
+            <a:endParaRPr lang="en-US" sz="1100" dirty="0"/>
+          </a:p>
+        </p:txBody>
+      </p:sp>
+      <p:sp>
+        <p:nvSpPr>
+          <p:cNvPr id="31" name="Text 29"/>
           <p:cNvSpPr txBox="1"/>
           <p:nvPr/>
         </p:nvSpPr>
@@ -22190,7 +22748,7 @@
       </p:sp>
       <p:sp>
         <p:nvSpPr>
-          <p:cNvPr id="6" name="Text 3"/>
+          <p:cNvPr id="32" name="Text 30"/>
           <p:cNvSpPr txBox="1"/>
           <p:nvPr/>
         </p:nvSpPr>
@@ -22229,7 +22787,7 @@
       </p:sp>
       <p:sp>
         <p:nvSpPr>
-          <p:cNvPr id="7" name="Text 4"/>
+          <p:cNvPr id="33" name="Text 31"/>
           <p:cNvSpPr txBox="1"/>
           <p:nvPr/>
         </p:nvSpPr>
@@ -22268,7 +22826,7 @@
       </p:sp>
       <p:sp>
         <p:nvSpPr>
-          <p:cNvPr id="8" name="Text 5"/>
+          <p:cNvPr id="34" name="Text 32"/>
           <p:cNvSpPr txBox="1"/>
           <p:nvPr/>
         </p:nvSpPr>
@@ -22307,7 +22865,7 @@
       </p:sp>
       <p:sp>
         <p:nvSpPr>
-          <p:cNvPr id="9" name="Text 6"/>
+          <p:cNvPr id="35" name="Text 33"/>
           <p:cNvSpPr txBox="1"/>
           <p:nvPr/>
         </p:nvSpPr>
@@ -22346,7 +22904,7 @@
       </p:sp>
       <p:sp>
         <p:nvSpPr>
-          <p:cNvPr id="10" name="Text 7"/>
+          <p:cNvPr id="36" name="Text 34"/>
           <p:cNvSpPr txBox="1"/>
           <p:nvPr/>
         </p:nvSpPr>

</xml_diff>

<commit_message>
Add a rose palette alongside the navy one
Every colour the deck uses is now a token in THEMES, so a second style
is a palette swap rather than a second copy of the slides. Both are
built from the same file:

    python3 thesis/build_slides.py            # navy
    python3 thesis/build_slides.py --rose     # pink

The rose palette runs deep berry for the dark slides and headings,
vivid rose for every highlight, and a muted teal for the positive
readings, which keeps the good/bad distinction legible without leaning
on the accent twice.

The category tags on the closing slide sit on a dark card, where the
accent and the positive colour both fell too close to the card behind
them. They now use tints of each, defined per palette.

Co-Authored-By: Claude Opus 5 <noreply@anthropic.com>
Claude-Session: https://claude.ai/code/session_01LTN1ToAz7S67GVeppJLK8m
</commit_message>
<xml_diff>
--- a/thesis/Defense_Slides.pptx
+++ b/thesis/Defense_Slides.pptx
@@ -25513,7 +25513,7 @@
             <a:r>
               <a:rPr sz="1500" b="1" i="0">
                 <a:solidFill>
-                  <a:srgbClr val="3FA7A0"/>
+                  <a:srgbClr val="7FD3CC"/>
                 </a:solidFill>
                 <a:latin typeface="Arial"/>
                 <a:cs typeface="Arial"/>
@@ -25644,7 +25644,7 @@
             <a:r>
               <a:rPr sz="1500" b="1" i="0">
                 <a:solidFill>
-                  <a:srgbClr val="E8A33D"/>
+                  <a:srgbClr val="F5C27A"/>
                 </a:solidFill>
                 <a:latin typeface="Arial"/>
                 <a:cs typeface="Arial"/>

</xml_diff>

<commit_message>
Call the Transformer a مبدل, and restore three deleted subsections
Rename throughout the report, the thesis, the glossary and both decks:
ترنسفورمر -> مبدل. The glossary entries keep the Latin original in their
footnotes, so "مبدل بینایی" still carries Vision Transformer (ViT) and
"سر مبدل" still carries Transformer Head.

The copy that came back was missing 2-9-2 (آمیزش در فضای ویژگی), 2-9-4
(تنظیم لاجیت برای دم بلند) and 3-3-3 (آمیزش و تنظیم لاجیت). Both remain
referenced elsewhere -- the hyperparameter table lists both coefficients
and chapter three reports their combined effect -- so the document
described settings it never introduced. Rebuilt from source, which also
restores sequential numbering; deleting a subsection in Word leaves a
hole because the number is literal text, not a Word list field.

Co-Authored-By: Claude Opus 5 <noreply@anthropic.com>
Claude-Session: https://claude.ai/code/session_01LTN1ToAz7S67GVeppJLK8m
</commit_message>
<xml_diff>
--- a/thesis/Defense_Slides.pptx
+++ b/thesis/Defense_Slides.pptx
@@ -5454,7 +5454,7 @@
                 <a:latin typeface="Vazir"/>
                 <a:cs typeface="Vazir"/>
               </a:rPr>
-              <a:t>یادگیری چندنمونه‌ای ضعیف‌نظارت با ستون فقرات ترنسفورمر ویدیویی</a:t>
+              <a:t>یادگیری چندنمونه‌ای ضعیف‌نظارت با ستون فقرات مبدل ویدیویی</a:t>
             </a:r>
           </a:p>
         </p:txBody>
@@ -13696,7 +13696,7 @@
                 <a:latin typeface="Vazir"/>
                 <a:cs typeface="Vazir"/>
               </a:rPr>
-              <a:t>سر ترنسفورمر</a:t>
+              <a:t>سر مبدل</a:t>
             </a:r>
           </a:p>
         </p:txBody>
@@ -14445,7 +14445,7 @@
                 <a:latin typeface="Vazir"/>
                 <a:cs typeface="Vazir"/>
               </a:rPr>
-              <a:t>سر ترنسفورمر روی محور زمان</a:t>
+              <a:t>سر مبدل روی محور زمان</a:t>
             </a:r>
           </a:p>
         </p:txBody>
@@ -15427,7 +15427,7 @@
                           <a:latin typeface="Vazir"/>
                           <a:cs typeface="Vazir"/>
                         </a:rPr>
-                        <a:t>سر ترنسفورمر زمانی</a:t>
+                        <a:t>سر مبدل زمانی</a:t>
                       </a:r>
                     </a:p>
                   </a:txBody>
@@ -24101,7 +24101,7 @@
                           <a:latin typeface="Vazir"/>
                           <a:cs typeface="Vazir"/>
                         </a:rPr>
-                        <a:t>مسیر دوم — سر ترنسفورمر زمانی</a:t>
+                        <a:t>مسیر دوم — سر مبدل زمانی</a:t>
                       </a:r>
                     </a:p>
                   </a:txBody>
@@ -25564,7 +25564,7 @@
                 <a:latin typeface="Vazir"/>
                 <a:cs typeface="Vazir"/>
               </a:rPr>
-              <a:t>اصلاح سه اشکال بنیادی، بازطراحی معماری با رمزگذار منجمد، سر ترنسفورمر زمانی، و پروتکل ارزیابی با کف نوفه</a:t>
+              <a:t>اصلاح سه اشکال بنیادی، بازطراحی معماری با رمزگذار منجمد، سر مبدل زمانی، و پروتکل ارزیابی با کف نوفه</a:t>
             </a:r>
           </a:p>
         </p:txBody>

</xml_diff>